<commit_message>
Update Final Report, presentation, and self-review checklist with Advanced Analytics section
</commit_message>
<xml_diff>
--- a/Bluestock_MF_Presentation.pptx
+++ b/Bluestock_MF_Presentation.pptx
@@ -4,6 +4,9 @@
   <p:sldMasterIdLst>
     <p:sldMasterId id="2147483648" r:id="rId1"/>
   </p:sldMasterIdLst>
+  <p:notesMasterIdLst>
+    <p:notesMasterId r:id="rId15"/>
+  </p:notesMasterIdLst>
   <p:sldIdLst>
     <p:sldId id="256" r:id="rId2"/>
     <p:sldId id="257" r:id="rId3"/>
@@ -13,16 +16,14 @@
     <p:sldId id="261" r:id="rId7"/>
     <p:sldId id="262" r:id="rId8"/>
     <p:sldId id="263" r:id="rId9"/>
-    <p:sldId id="264" r:id="rId10"/>
-    <p:sldId id="265" r:id="rId11"/>
-    <p:sldId id="266" r:id="rId12"/>
-    <p:sldId id="267" r:id="rId13"/>
+    <p:sldId id="268" r:id="rId10"/>
+    <p:sldId id="264" r:id="rId11"/>
+    <p:sldId id="265" r:id="rId12"/>
+    <p:sldId id="266" r:id="rId13"/>
+    <p:sldId id="267" r:id="rId14"/>
   </p:sldIdLst>
-  <p:notesMasterIdLst>
-    <p:notesMasterId r:id="rId14"/>
-  </p:notesMasterIdLst>
-  <p:sldSz cx="12161520" cy="6858000"/>
-  <p:notesSz cx="6858000" cy="12161520"/>
+  <p:sldSz cx="12161838" cy="6858000"/>
+  <p:notesSz cx="6858000" cy="12161838"/>
   <p:defaultTextStyle>
     <a:lvl1pPr marL="0" algn="l" defTabSz="914400" rtl="0" eaLnBrk="1" latinLnBrk="0" hangingPunct="1">
       <a:defRPr sz="1800" kern="1200">
@@ -115,6 +116,11 @@
       </a:defRPr>
     </a:lvl9pPr>
   </p:defaultTextStyle>
+  <p:extLst>
+    <p:ext uri="{EFAFB233-063F-42B5-8137-9DF3F51BA10A}">
+      <p15:sldGuideLst xmlns:p15="http://schemas.microsoft.com/office/powerpoint/2012/main"/>
+    </p:ext>
+  </p:extLst>
 </p:presentation>
 </file>
 
@@ -140,234 +146,10 @@
           <a:chExt cx="0" cy="0"/>
         </a:xfrm>
       </p:grpSpPr>
-      <p:sp>
-        <p:nvSpPr>
-          <p:cNvPr id="2" name="Header Placeholder 1"/>
-          <p:cNvSpPr>
-            <a:spLocks noGrp="1"/>
-          </p:cNvSpPr>
-          <p:nvPr>
-            <p:ph type="hdr" sz="quarter"/>
-          </p:nvPr>
-        </p:nvSpPr>
-        <p:spPr>
-          <a:xfrm>
-            <a:off x="0" y="0"/>
-            <a:ext cx="2971800" cy="458788"/>
-          </a:xfrm>
-          <a:prstGeom prst="rect">
-            <a:avLst/>
-          </a:prstGeom>
-        </p:spPr>
-        <p:txBody>
-          <a:bodyPr vert="horz" lIns="91440" tIns="45720" rIns="91440" bIns="45720" rtlCol="0"/>
-          <a:lstStyle>
-            <a:lvl1pPr algn="l">
-              <a:defRPr sz="1200"/>
-            </a:lvl1pPr>
-          </a:lstStyle>
-          <a:p>
-            <a:endParaRPr lang="en-US"/>
-          </a:p>
-        </p:txBody>
-      </p:sp>
-      <p:sp>
-        <p:nvSpPr>
-          <p:cNvPr id="3" name="Date Placeholder 2"/>
-          <p:cNvSpPr>
-            <a:spLocks noGrp="1"/>
-          </p:cNvSpPr>
-          <p:nvPr>
-            <p:ph type="dt" idx="1"/>
-          </p:nvPr>
-        </p:nvSpPr>
-        <p:spPr>
-          <a:xfrm>
-            <a:off x="3884613" y="0"/>
-            <a:ext cx="2971800" cy="458788"/>
-          </a:xfrm>
-          <a:prstGeom prst="rect">
-            <a:avLst/>
-          </a:prstGeom>
-        </p:spPr>
-        <p:txBody>
-          <a:bodyPr vert="horz" lIns="91440" tIns="45720" rIns="91440" bIns="45720" rtlCol="0"/>
-          <a:lstStyle>
-            <a:lvl1pPr algn="r">
-              <a:defRPr sz="1200"/>
-            </a:lvl1pPr>
-          </a:lstStyle>
-          <a:p>
-            <a:fld id="{5282F153-3F37-0F45-9E97-73ACFA13230C}" type="datetimeFigureOut">
-              <a:rPr lang="en-US"/>
-              <a:t>7/23/19</a:t>
-            </a:fld>
-            <a:endParaRPr lang="en-US"/>
-          </a:p>
-        </p:txBody>
-      </p:sp>
-      <p:sp>
-        <p:nvSpPr>
-          <p:cNvPr id="4" name="Slide Image Placeholder 3"/>
-          <p:cNvSpPr>
-            <a:spLocks noGrp="1" noRot="1" noChangeAspect="1"/>
-          </p:cNvSpPr>
-          <p:nvPr>
-            <p:ph type="sldImg" idx="2"/>
-          </p:nvPr>
-        </p:nvSpPr>
-        <p:spPr>
-          <a:xfrm>
-            <a:off x="685800" y="1143000"/>
-            <a:ext cx="5486400" cy="3086100"/>
-          </a:xfrm>
-          <a:prstGeom prst="rect">
-            <a:avLst/>
-          </a:prstGeom>
-          <a:noFill/>
-          <a:ln w="12700">
-            <a:solidFill>
-              <a:prstClr val="black"/>
-            </a:solidFill>
-          </a:ln>
-        </p:spPr>
-        <p:txBody>
-          <a:bodyPr vert="horz" lIns="91440" tIns="45720" rIns="91440" bIns="45720" rtlCol="0" anchor="ctr"/>
-          <a:lstStyle/>
-          <a:p>
-            <a:endParaRPr lang="en-US"/>
-          </a:p>
-        </p:txBody>
-      </p:sp>
-      <p:sp>
-        <p:nvSpPr>
-          <p:cNvPr id="5" name="Notes Placeholder 4"/>
-          <p:cNvSpPr>
-            <a:spLocks noGrp="1"/>
-          </p:cNvSpPr>
-          <p:nvPr>
-            <p:ph type="body" sz="quarter" idx="3"/>
-          </p:nvPr>
-        </p:nvSpPr>
-        <p:spPr>
-          <a:xfrm>
-            <a:off x="685800" y="4400550"/>
-            <a:ext cx="5486400" cy="3600450"/>
-          </a:xfrm>
-          <a:prstGeom prst="rect">
-            <a:avLst/>
-          </a:prstGeom>
-        </p:spPr>
-        <p:txBody>
-          <a:bodyPr vert="horz" lIns="91440" tIns="45720" rIns="91440" bIns="45720" rtlCol="0"/>
-          <a:lstStyle/>
-          <a:p>
-            <a:pPr lvl="0"/>
-            <a:r>
-              <a:rPr lang="en-US"/>
-              <a:t>Click to edit Master text styles</a:t>
-            </a:r>
-          </a:p>
-          <a:p>
-            <a:pPr lvl="1"/>
-            <a:r>
-              <a:rPr lang="en-US"/>
-              <a:t>Second level</a:t>
-            </a:r>
-          </a:p>
-          <a:p>
-            <a:pPr lvl="2"/>
-            <a:r>
-              <a:rPr lang="en-US"/>
-              <a:t>Third level</a:t>
-            </a:r>
-          </a:p>
-          <a:p>
-            <a:pPr lvl="3"/>
-            <a:r>
-              <a:rPr lang="en-US"/>
-              <a:t>Fourth level</a:t>
-            </a:r>
-          </a:p>
-          <a:p>
-            <a:pPr lvl="4"/>
-            <a:r>
-              <a:rPr lang="en-US"/>
-              <a:t>Fifth level</a:t>
-            </a:r>
-          </a:p>
-        </p:txBody>
-      </p:sp>
-      <p:sp>
-        <p:nvSpPr>
-          <p:cNvPr id="6" name="Footer Placeholder 5"/>
-          <p:cNvSpPr>
-            <a:spLocks noGrp="1"/>
-          </p:cNvSpPr>
-          <p:nvPr>
-            <p:ph type="ftr" sz="quarter" idx="4"/>
-          </p:nvPr>
-        </p:nvSpPr>
-        <p:spPr>
-          <a:xfrm>
-            <a:off x="0" y="8685213"/>
-            <a:ext cx="2971800" cy="458787"/>
-          </a:xfrm>
-          <a:prstGeom prst="rect">
-            <a:avLst/>
-          </a:prstGeom>
-        </p:spPr>
-        <p:txBody>
-          <a:bodyPr vert="horz" lIns="91440" tIns="45720" rIns="91440" bIns="45720" rtlCol="0" anchor="b"/>
-          <a:lstStyle>
-            <a:lvl1pPr algn="l">
-              <a:defRPr sz="1200"/>
-            </a:lvl1pPr>
-          </a:lstStyle>
-          <a:p>
-            <a:endParaRPr lang="en-US"/>
-          </a:p>
-        </p:txBody>
-      </p:sp>
-      <p:sp>
-        <p:nvSpPr>
-          <p:cNvPr id="7" name="Slide Number Placeholder 6"/>
-          <p:cNvSpPr>
-            <a:spLocks noGrp="1"/>
-          </p:cNvSpPr>
-          <p:nvPr>
-            <p:ph type="sldNum" sz="quarter" idx="5"/>
-          </p:nvPr>
-        </p:nvSpPr>
-        <p:spPr>
-          <a:xfrm>
-            <a:off x="3884613" y="8685213"/>
-            <a:ext cx="2971800" cy="458787"/>
-          </a:xfrm>
-          <a:prstGeom prst="rect">
-            <a:avLst/>
-          </a:prstGeom>
-        </p:spPr>
-        <p:txBody>
-          <a:bodyPr vert="horz" lIns="91440" tIns="45720" rIns="91440" bIns="45720" rtlCol="0" anchor="b"/>
-          <a:lstStyle>
-            <a:lvl1pPr algn="r">
-              <a:defRPr sz="1200"/>
-            </a:lvl1pPr>
-          </a:lstStyle>
-          <a:p>
-            <a:fld id="{CE5E9CC1-C706-0F49-92D6-E571CC5EEA8F}" type="slidenum">
-              <a:rPr lang="en-US"/>
-              <a:t>‹#›</a:t>
-            </a:fld>
-            <a:endParaRPr lang="en-US"/>
-          </a:p>
-        </p:txBody>
-      </p:sp>
     </p:spTree>
     <p:extLst>
       <p:ext uri="{BB962C8B-B14F-4D97-AF65-F5344CB8AC3E}">
-        <p14:creationId xmlns:p14="http://schemas.microsoft.com/office/powerpoint/2010/main" val="1024086991"/>
+        <p14:creationId xmlns:p14="http://schemas.microsoft.com/office/powerpoint/2010/main" val="629327745"/>
       </p:ext>
     </p:extLst>
   </p:cSld>
@@ -511,10 +293,6 @@
           <a:bodyPr/>
           <a:lstStyle/>
           <a:p>
-            <a:r>
-              <a:rPr lang="en-US" dirty="0"/>
-              <a:t/>
-            </a:r>
             <a:endParaRPr lang="en-US" dirty="0"/>
           </a:p>
         </p:txBody>
@@ -599,10 +377,6 @@
           <a:bodyPr/>
           <a:lstStyle/>
           <a:p>
-            <a:r>
-              <a:rPr lang="en-US" dirty="0"/>
-              <a:t/>
-            </a:r>
             <a:endParaRPr lang="en-US" dirty="0"/>
           </a:p>
         </p:txBody>
@@ -624,7 +398,7 @@
           <a:p>
             <a:fld id="{F7021451-1387-4CA6-816F-3879F97B5CBC}" type="slidenum">
               <a:rPr lang="en-US"/>
-              <a:t>10</a:t>
+              <a:t>11</a:t>
             </a:fld>
             <a:endParaRPr lang="en-US"/>
           </a:p>
@@ -687,10 +461,6 @@
           <a:bodyPr/>
           <a:lstStyle/>
           <a:p>
-            <a:r>
-              <a:rPr lang="en-US" dirty="0"/>
-              <a:t/>
-            </a:r>
             <a:endParaRPr lang="en-US" dirty="0"/>
           </a:p>
         </p:txBody>
@@ -712,7 +482,7 @@
           <a:p>
             <a:fld id="{F7021451-1387-4CA6-816F-3879F97B5CBC}" type="slidenum">
               <a:rPr lang="en-US"/>
-              <a:t>11</a:t>
+              <a:t>12</a:t>
             </a:fld>
             <a:endParaRPr lang="en-US"/>
           </a:p>
@@ -775,10 +545,6 @@
           <a:bodyPr/>
           <a:lstStyle/>
           <a:p>
-            <a:r>
-              <a:rPr lang="en-US" dirty="0"/>
-              <a:t/>
-            </a:r>
             <a:endParaRPr lang="en-US" dirty="0"/>
           </a:p>
         </p:txBody>
@@ -800,7 +566,7 @@
           <a:p>
             <a:fld id="{F7021451-1387-4CA6-816F-3879F97B5CBC}" type="slidenum">
               <a:rPr lang="en-US"/>
-              <a:t>12</a:t>
+              <a:t>13</a:t>
             </a:fld>
             <a:endParaRPr lang="en-US"/>
           </a:p>
@@ -863,10 +629,6 @@
           <a:bodyPr/>
           <a:lstStyle/>
           <a:p>
-            <a:r>
-              <a:rPr lang="en-US" dirty="0"/>
-              <a:t/>
-            </a:r>
             <a:endParaRPr lang="en-US" dirty="0"/>
           </a:p>
         </p:txBody>
@@ -951,10 +713,6 @@
           <a:bodyPr/>
           <a:lstStyle/>
           <a:p>
-            <a:r>
-              <a:rPr lang="en-US" dirty="0"/>
-              <a:t/>
-            </a:r>
             <a:endParaRPr lang="en-US" dirty="0"/>
           </a:p>
         </p:txBody>
@@ -1039,10 +797,6 @@
           <a:bodyPr/>
           <a:lstStyle/>
           <a:p>
-            <a:r>
-              <a:rPr lang="en-US" dirty="0"/>
-              <a:t/>
-            </a:r>
             <a:endParaRPr lang="en-US" dirty="0"/>
           </a:p>
         </p:txBody>
@@ -1127,10 +881,6 @@
           <a:bodyPr/>
           <a:lstStyle/>
           <a:p>
-            <a:r>
-              <a:rPr lang="en-US" dirty="0"/>
-              <a:t/>
-            </a:r>
             <a:endParaRPr lang="en-US" dirty="0"/>
           </a:p>
         </p:txBody>
@@ -1215,10 +965,6 @@
           <a:bodyPr/>
           <a:lstStyle/>
           <a:p>
-            <a:r>
-              <a:rPr lang="en-US" dirty="0"/>
-              <a:t/>
-            </a:r>
             <a:endParaRPr lang="en-US" dirty="0"/>
           </a:p>
         </p:txBody>
@@ -1303,10 +1049,6 @@
           <a:bodyPr/>
           <a:lstStyle/>
           <a:p>
-            <a:r>
-              <a:rPr lang="en-US" dirty="0"/>
-              <a:t/>
-            </a:r>
             <a:endParaRPr lang="en-US" dirty="0"/>
           </a:p>
         </p:txBody>
@@ -1391,10 +1133,6 @@
           <a:bodyPr/>
           <a:lstStyle/>
           <a:p>
-            <a:r>
-              <a:rPr lang="en-US" dirty="0"/>
-              <a:t/>
-            </a:r>
             <a:endParaRPr lang="en-US" dirty="0"/>
           </a:p>
         </p:txBody>
@@ -1479,10 +1217,6 @@
           <a:bodyPr/>
           <a:lstStyle/>
           <a:p>
-            <a:r>
-              <a:rPr lang="en-US" dirty="0"/>
-              <a:t/>
-            </a:r>
             <a:endParaRPr lang="en-US" dirty="0"/>
           </a:p>
         </p:txBody>
@@ -1504,7 +1238,7 @@
           <a:p>
             <a:fld id="{F7021451-1387-4CA6-816F-3879F97B5CBC}" type="slidenum">
               <a:rPr lang="en-US"/>
-              <a:t>9</a:t>
+              <a:t>10</a:t>
             </a:fld>
             <a:endParaRPr lang="en-US"/>
           </a:p>
@@ -1556,6 +1290,11 @@
 <file path=ppt/slideMasters/slideMaster1.xml><?xml version="1.0" encoding="utf-8"?>
 <p:sldMaster xmlns:a="http://schemas.openxmlformats.org/drawingml/2006/main" xmlns:r="http://schemas.openxmlformats.org/officeDocument/2006/relationships" xmlns:p="http://schemas.openxmlformats.org/presentationml/2006/main">
   <p:cSld>
+    <p:bg>
+      <p:bgRef idx="1001">
+        <a:schemeClr val="bg1"/>
+      </p:bgRef>
+    </p:bg>
     <p:spTree>
       <p:nvGrpSpPr>
         <p:cNvPr id="1" name=""/>
@@ -1866,6 +1605,13 @@
           </a:solidFill>
           <a:ln/>
         </p:spPr>
+        <p:txBody>
+          <a:bodyPr/>
+          <a:lstStyle/>
+          <a:p>
+            <a:endParaRPr lang="en-US"/>
+          </a:p>
+        </p:txBody>
       </p:sp>
       <p:sp>
         <p:nvSpPr>
@@ -1888,11 +1634,11 @@
           <a:bodyPr wrap="square" rtlCol="0" anchor="ctr"/>
           <a:lstStyle/>
           <a:p>
-            <a:pPr indent="0" marL="0">
+            <a:pPr marL="0" indent="0">
               <a:buNone/>
             </a:pPr>
             <a:r>
-              <a:rPr lang="en-US" sz="1800" b="1" spc="200" kern="0" dirty="0">
+              <a:rPr lang="en-US" sz="1800" b="1" kern="0" spc="200" dirty="0">
                 <a:solidFill>
                   <a:srgbClr val="D8CCF0"/>
                 </a:solidFill>
@@ -1927,7 +1673,7 @@
           <a:bodyPr wrap="square" rtlCol="0" anchor="ctr"/>
           <a:lstStyle/>
           <a:p>
-            <a:pPr indent="0" marL="0">
+            <a:pPr marL="0" indent="0">
               <a:buNone/>
             </a:pPr>
             <a:r>
@@ -1966,7 +1712,7 @@
           <a:bodyPr wrap="square" rtlCol="0" anchor="ctr"/>
           <a:lstStyle/>
           <a:p>
-            <a:pPr indent="0" marL="0">
+            <a:pPr marL="0" indent="0">
               <a:buNone/>
             </a:pPr>
             <a:r>
@@ -2005,9 +1751,6 @@
           <a:bodyPr wrap="square" rtlCol="0" anchor="ctr"/>
           <a:lstStyle/>
           <a:p>
-            <a:pPr indent="0" marL="0">
-              <a:buNone/>
-            </a:pPr>
             <a:r>
               <a:rPr lang="en-US" sz="1300" dirty="0">
                 <a:solidFill>
@@ -2017,7 +1760,7 @@
                 <a:ea typeface="Calibri" pitchFamily="34" charset="-122"/>
                 <a:cs typeface="Calibri" pitchFamily="34" charset="-120"/>
               </a:rPr>
-              <a:t>Janna Haleema  |  Remote Data Analytics Intern  |  August 2026</a:t>
+              <a:t>Haleema Janna |  Remote Data Analytics Intern  |  August 2026</a:t>
             </a:r>
             <a:endParaRPr lang="en-US" sz="1300" dirty="0"/>
           </a:p>
@@ -2032,6 +1775,262 @@
 </file>
 
 <file path=ppt/slides/slide10.xml><?xml version="1.0" encoding="utf-8"?>
+<p:sld xmlns:a="http://schemas.openxmlformats.org/drawingml/2006/main" xmlns:r="http://schemas.openxmlformats.org/officeDocument/2006/relationships" xmlns:p="http://schemas.openxmlformats.org/presentationml/2006/main">
+  <p:cSld name="Slide 9">
+    <p:spTree>
+      <p:nvGrpSpPr>
+        <p:cNvPr id="1" name=""/>
+        <p:cNvGrpSpPr/>
+        <p:nvPr/>
+      </p:nvGrpSpPr>
+      <p:grpSpPr>
+        <a:xfrm>
+          <a:off x="0" y="0"/>
+          <a:ext cx="0" cy="0"/>
+          <a:chOff x="0" y="0"/>
+          <a:chExt cx="0" cy="0"/>
+        </a:xfrm>
+      </p:grpSpPr>
+      <p:sp>
+        <p:nvSpPr>
+          <p:cNvPr id="2" name="Text 0"/>
+          <p:cNvSpPr/>
+          <p:nvPr/>
+        </p:nvSpPr>
+        <p:spPr>
+          <a:xfrm>
+            <a:off x="548640" y="365760"/>
+            <a:ext cx="11064240" cy="640080"/>
+          </a:xfrm>
+          <a:prstGeom prst="rect">
+            <a:avLst/>
+          </a:prstGeom>
+          <a:noFill/>
+          <a:ln/>
+        </p:spPr>
+        <p:txBody>
+          <a:bodyPr wrap="square" rtlCol="0" anchor="ctr"/>
+          <a:lstStyle/>
+          <a:p>
+            <a:pPr marL="0" indent="0">
+              <a:buNone/>
+            </a:pPr>
+            <a:r>
+              <a:rPr lang="en-US" sz="3000" b="1" dirty="0">
+                <a:solidFill>
+                  <a:srgbClr val="1F1F1F"/>
+                </a:solidFill>
+                <a:latin typeface="Calibri" pitchFamily="34" charset="0"/>
+                <a:ea typeface="Calibri" pitchFamily="34" charset="-122"/>
+                <a:cs typeface="Calibri" pitchFamily="34" charset="-120"/>
+              </a:rPr>
+              <a:t>Dashboard: Industry Overview &amp; Fund Performance</a:t>
+            </a:r>
+            <a:endParaRPr lang="en-US" sz="3000" dirty="0"/>
+          </a:p>
+        </p:txBody>
+      </p:sp>
+      <p:pic>
+        <p:nvPicPr>
+          <p:cNvPr id="3" name="Image 0" descr="/home/claude/pptx_build/images/page1_industry_overview.png"/>
+          <p:cNvPicPr>
+            <a:picLocks noChangeAspect="1"/>
+          </p:cNvPicPr>
+          <p:nvPr/>
+        </p:nvPicPr>
+        <p:blipFill>
+          <a:blip r:embed="rId3"/>
+          <a:stretch>
+            <a:fillRect/>
+          </a:stretch>
+        </p:blipFill>
+        <p:spPr>
+          <a:xfrm>
+            <a:off x="365760" y="1554480"/>
+            <a:ext cx="5806440" cy="3566160"/>
+          </a:xfrm>
+          <a:prstGeom prst="rect">
+            <a:avLst/>
+          </a:prstGeom>
+        </p:spPr>
+      </p:pic>
+      <p:pic>
+        <p:nvPicPr>
+          <p:cNvPr id="4" name="Image 1" descr="/home/claude/pptx_build/images/page2_fund_performance.png"/>
+          <p:cNvPicPr>
+            <a:picLocks noChangeAspect="1"/>
+          </p:cNvPicPr>
+          <p:nvPr/>
+        </p:nvPicPr>
+        <p:blipFill>
+          <a:blip r:embed="rId4"/>
+          <a:stretch>
+            <a:fillRect/>
+          </a:stretch>
+        </p:blipFill>
+        <p:spPr>
+          <a:xfrm>
+            <a:off x="6309360" y="1554480"/>
+            <a:ext cx="5440680" cy="3566160"/>
+          </a:xfrm>
+          <a:prstGeom prst="rect">
+            <a:avLst/>
+          </a:prstGeom>
+        </p:spPr>
+      </p:pic>
+      <p:sp>
+        <p:nvSpPr>
+          <p:cNvPr id="5" name="Shape 1"/>
+          <p:cNvSpPr/>
+          <p:nvPr/>
+        </p:nvSpPr>
+        <p:spPr>
+          <a:xfrm>
+            <a:off x="365760" y="5257800"/>
+            <a:ext cx="11384280" cy="1051560"/>
+          </a:xfrm>
+          <a:prstGeom prst="rect">
+            <a:avLst/>
+          </a:prstGeom>
+          <a:solidFill>
+            <a:srgbClr val="F2F0F7"/>
+          </a:solidFill>
+          <a:ln/>
+        </p:spPr>
+        <p:txBody>
+          <a:bodyPr/>
+          <a:lstStyle/>
+          <a:p>
+            <a:endParaRPr lang="en-US"/>
+          </a:p>
+        </p:txBody>
+      </p:sp>
+      <p:sp>
+        <p:nvSpPr>
+          <p:cNvPr id="6" name="Text 2"/>
+          <p:cNvSpPr/>
+          <p:nvPr/>
+        </p:nvSpPr>
+        <p:spPr>
+          <a:xfrm>
+            <a:off x="685800" y="5394960"/>
+            <a:ext cx="10744200" cy="777240"/>
+          </a:xfrm>
+          <a:prstGeom prst="rect">
+            <a:avLst/>
+          </a:prstGeom>
+          <a:noFill/>
+          <a:ln/>
+        </p:spPr>
+        <p:txBody>
+          <a:bodyPr wrap="square" rtlCol="0" anchor="ctr"/>
+          <a:lstStyle/>
+          <a:p>
+            <a:pPr marL="0" indent="0">
+              <a:buNone/>
+            </a:pPr>
+            <a:r>
+              <a:rPr lang="en-US" sz="1300" dirty="0">
+                <a:solidFill>
+                  <a:srgbClr val="1F1F1F"/>
+                </a:solidFill>
+                <a:latin typeface="Calibri" pitchFamily="34" charset="0"/>
+                <a:ea typeface="Calibri" pitchFamily="34" charset="-122"/>
+                <a:cs typeface="Calibri" pitchFamily="34" charset="-120"/>
+              </a:rPr>
+              <a:t>4-page interactive Power BI dashboard with KPI cards, AUM trends, a return-vs-risk scatter plot, and a sortable fund scorecard — plus drill-through to per-fund NAV detail.</a:t>
+            </a:r>
+            <a:endParaRPr lang="en-US" sz="1300" dirty="0"/>
+          </a:p>
+        </p:txBody>
+      </p:sp>
+      <p:sp>
+        <p:nvSpPr>
+          <p:cNvPr id="7" name="Text 3"/>
+          <p:cNvSpPr/>
+          <p:nvPr/>
+        </p:nvSpPr>
+        <p:spPr>
+          <a:xfrm>
+            <a:off x="365760" y="6537960"/>
+            <a:ext cx="7315200" cy="274320"/>
+          </a:xfrm>
+          <a:prstGeom prst="rect">
+            <a:avLst/>
+          </a:prstGeom>
+          <a:noFill/>
+          <a:ln/>
+        </p:spPr>
+        <p:txBody>
+          <a:bodyPr wrap="square" rtlCol="0" anchor="ctr"/>
+          <a:lstStyle/>
+          <a:p>
+            <a:pPr marL="0" indent="0">
+              <a:buNone/>
+            </a:pPr>
+            <a:r>
+              <a:rPr lang="en-US" sz="900" dirty="0">
+                <a:solidFill>
+                  <a:srgbClr val="595959"/>
+                </a:solidFill>
+                <a:latin typeface="Calibri" pitchFamily="34" charset="0"/>
+                <a:ea typeface="Calibri" pitchFamily="34" charset="-122"/>
+                <a:cs typeface="Calibri" pitchFamily="34" charset="-120"/>
+              </a:rPr>
+              <a:t>Bluestock Fintech — Mutual Fund Analytics Capstone</a:t>
+            </a:r>
+            <a:endParaRPr lang="en-US" sz="900" dirty="0"/>
+          </a:p>
+        </p:txBody>
+      </p:sp>
+      <p:sp>
+        <p:nvSpPr>
+          <p:cNvPr id="8" name="Text 4"/>
+          <p:cNvSpPr/>
+          <p:nvPr/>
+        </p:nvSpPr>
+        <p:spPr>
+          <a:xfrm>
+            <a:off x="11521440" y="6537960"/>
+            <a:ext cx="365760" cy="274320"/>
+          </a:xfrm>
+          <a:prstGeom prst="rect">
+            <a:avLst/>
+          </a:prstGeom>
+          <a:noFill/>
+          <a:ln/>
+        </p:spPr>
+        <p:txBody>
+          <a:bodyPr wrap="square" rtlCol="0" anchor="ctr"/>
+          <a:lstStyle/>
+          <a:p>
+            <a:pPr marL="0" indent="0" algn="r">
+              <a:buNone/>
+            </a:pPr>
+            <a:r>
+              <a:rPr lang="en-US" sz="900" dirty="0">
+                <a:solidFill>
+                  <a:srgbClr val="595959"/>
+                </a:solidFill>
+                <a:latin typeface="Calibri" pitchFamily="34" charset="0"/>
+                <a:ea typeface="Calibri" pitchFamily="34" charset="-122"/>
+                <a:cs typeface="Calibri" pitchFamily="34" charset="-120"/>
+              </a:rPr>
+              <a:t>9</a:t>
+            </a:r>
+            <a:endParaRPr lang="en-US" sz="900" dirty="0"/>
+          </a:p>
+        </p:txBody>
+      </p:sp>
+    </p:spTree>
+  </p:cSld>
+  <p:clrMapOvr>
+    <a:masterClrMapping/>
+  </p:clrMapOvr>
+</p:sld>
+</file>
+
+<file path=ppt/slides/slide11.xml><?xml version="1.0" encoding="utf-8"?>
 <p:sld xmlns:a="http://schemas.openxmlformats.org/drawingml/2006/main" xmlns:r="http://schemas.openxmlformats.org/officeDocument/2006/relationships" xmlns:p="http://schemas.openxmlformats.org/presentationml/2006/main">
   <p:cSld name="Slide 10">
     <p:spTree>
@@ -2069,7 +2068,7 @@
           <a:bodyPr wrap="square" rtlCol="0" anchor="ctr"/>
           <a:lstStyle/>
           <a:p>
-            <a:pPr indent="0" marL="0">
+            <a:pPr marL="0" indent="0">
               <a:buNone/>
             </a:pPr>
             <a:r>
@@ -2089,14 +2088,14 @@
       </p:sp>
       <p:pic>
         <p:nvPicPr>
-          <p:cNvPr id="3" name="Image 0" descr="/home/claude/pptx_build/images/page3_investor_analytics.png">    </p:cNvPr>
+          <p:cNvPr id="3" name="Image 0" descr="/home/claude/pptx_build/images/page3_investor_analytics.png"/>
           <p:cNvPicPr>
             <a:picLocks noChangeAspect="1"/>
           </p:cNvPicPr>
           <p:nvPr/>
         </p:nvPicPr>
         <p:blipFill>
-          <a:blip r:embed="rId1"/>
+          <a:blip r:embed="rId3"/>
           <a:stretch>
             <a:fillRect/>
           </a:stretch>
@@ -2113,14 +2112,14 @@
       </p:pic>
       <p:pic>
         <p:nvPicPr>
-          <p:cNvPr id="4" name="Image 1" descr="/home/claude/pptx_build/images/page4_sip_market_trends.png">    </p:cNvPr>
+          <p:cNvPr id="4" name="Image 1" descr="/home/claude/pptx_build/images/page4_sip_market_trends.png"/>
           <p:cNvPicPr>
             <a:picLocks noChangeAspect="1"/>
           </p:cNvPicPr>
           <p:nvPr/>
         </p:nvPicPr>
         <p:blipFill>
-          <a:blip r:embed="rId2"/>
+          <a:blip r:embed="rId4"/>
           <a:stretch>
             <a:fillRect/>
           </a:stretch>
@@ -2154,6 +2153,13 @@
           </a:solidFill>
           <a:ln/>
         </p:spPr>
+        <p:txBody>
+          <a:bodyPr/>
+          <a:lstStyle/>
+          <a:p>
+            <a:endParaRPr lang="en-US"/>
+          </a:p>
+        </p:txBody>
       </p:sp>
       <p:sp>
         <p:nvSpPr>
@@ -2176,7 +2182,7 @@
           <a:bodyPr wrap="square" rtlCol="0" anchor="ctr"/>
           <a:lstStyle/>
           <a:p>
-            <a:pPr indent="0" marL="0">
+            <a:pPr marL="0" indent="0">
               <a:buNone/>
             </a:pPr>
             <a:r>
@@ -2215,7 +2221,7 @@
           <a:bodyPr wrap="square" rtlCol="0" anchor="ctr"/>
           <a:lstStyle/>
           <a:p>
-            <a:pPr indent="0" marL="0">
+            <a:pPr marL="0" indent="0">
               <a:buNone/>
             </a:pPr>
             <a:r>
@@ -2254,7 +2260,7 @@
           <a:bodyPr wrap="square" rtlCol="0" anchor="ctr"/>
           <a:lstStyle/>
           <a:p>
-            <a:pPr algn="r" indent="0" marL="0">
+            <a:pPr marL="0" indent="0" algn="r">
               <a:buNone/>
             </a:pPr>
             <a:r>
@@ -2280,7 +2286,7 @@
 </p:sld>
 </file>
 
-<file path=ppt/slides/slide11.xml><?xml version="1.0" encoding="utf-8"?>
+<file path=ppt/slides/slide12.xml><?xml version="1.0" encoding="utf-8"?>
 <p:sld xmlns:a="http://schemas.openxmlformats.org/drawingml/2006/main" xmlns:r="http://schemas.openxmlformats.org/officeDocument/2006/relationships" xmlns:p="http://schemas.openxmlformats.org/presentationml/2006/main">
   <p:cSld name="Slide 11">
     <p:spTree>
@@ -2318,7 +2324,7 @@
           <a:bodyPr wrap="square" rtlCol="0" anchor="ctr"/>
           <a:lstStyle/>
           <a:p>
-            <a:pPr indent="0" marL="0">
+            <a:pPr marL="0" indent="0">
               <a:buNone/>
             </a:pPr>
             <a:r>
@@ -2355,6 +2361,13 @@
           </a:solidFill>
           <a:ln/>
         </p:spPr>
+        <p:txBody>
+          <a:bodyPr/>
+          <a:lstStyle/>
+          <a:p>
+            <a:endParaRPr lang="en-US"/>
+          </a:p>
+        </p:txBody>
       </p:sp>
       <p:sp>
         <p:nvSpPr>
@@ -2375,6 +2388,13 @@
           </a:solidFill>
           <a:ln/>
         </p:spPr>
+        <p:txBody>
+          <a:bodyPr/>
+          <a:lstStyle/>
+          <a:p>
+            <a:endParaRPr lang="en-US"/>
+          </a:p>
+        </p:txBody>
       </p:sp>
       <p:sp>
         <p:nvSpPr>
@@ -2397,7 +2417,7 @@
           <a:bodyPr wrap="square" rtlCol="0" anchor="ctr"/>
           <a:lstStyle/>
           <a:p>
-            <a:pPr algn="ctr" indent="0" marL="0">
+            <a:pPr marL="0" indent="0" algn="ctr">
               <a:buNone/>
             </a:pPr>
             <a:r>
@@ -2436,7 +2456,7 @@
           <a:bodyPr wrap="square" rtlCol="0" anchor="ctr"/>
           <a:lstStyle/>
           <a:p>
-            <a:pPr indent="0" marL="0">
+            <a:pPr marL="0" indent="0">
               <a:buNone/>
             </a:pPr>
             <a:r>
@@ -2475,7 +2495,7 @@
           <a:bodyPr wrap="square" rtlCol="0" anchor="t"/>
           <a:lstStyle/>
           <a:p>
-            <a:pPr indent="0" marL="0">
+            <a:pPr marL="0" indent="0">
               <a:buNone/>
             </a:pPr>
             <a:r>
@@ -2512,6 +2532,13 @@
           </a:solidFill>
           <a:ln/>
         </p:spPr>
+        <p:txBody>
+          <a:bodyPr/>
+          <a:lstStyle/>
+          <a:p>
+            <a:endParaRPr lang="en-US"/>
+          </a:p>
+        </p:txBody>
       </p:sp>
       <p:sp>
         <p:nvSpPr>
@@ -2532,6 +2559,13 @@
           </a:solidFill>
           <a:ln/>
         </p:spPr>
+        <p:txBody>
+          <a:bodyPr/>
+          <a:lstStyle/>
+          <a:p>
+            <a:endParaRPr lang="en-US"/>
+          </a:p>
+        </p:txBody>
       </p:sp>
       <p:sp>
         <p:nvSpPr>
@@ -2554,7 +2588,7 @@
           <a:bodyPr wrap="square" rtlCol="0" anchor="ctr"/>
           <a:lstStyle/>
           <a:p>
-            <a:pPr algn="ctr" indent="0" marL="0">
+            <a:pPr marL="0" indent="0" algn="ctr">
               <a:buNone/>
             </a:pPr>
             <a:r>
@@ -2593,7 +2627,7 @@
           <a:bodyPr wrap="square" rtlCol="0" anchor="ctr"/>
           <a:lstStyle/>
           <a:p>
-            <a:pPr indent="0" marL="0">
+            <a:pPr marL="0" indent="0">
               <a:buNone/>
             </a:pPr>
             <a:r>
@@ -2632,7 +2666,7 @@
           <a:bodyPr wrap="square" rtlCol="0" anchor="t"/>
           <a:lstStyle/>
           <a:p>
-            <a:pPr indent="0" marL="0">
+            <a:pPr marL="0" indent="0">
               <a:buNone/>
             </a:pPr>
             <a:r>
@@ -2669,6 +2703,13 @@
           </a:solidFill>
           <a:ln/>
         </p:spPr>
+        <p:txBody>
+          <a:bodyPr/>
+          <a:lstStyle/>
+          <a:p>
+            <a:endParaRPr lang="en-US"/>
+          </a:p>
+        </p:txBody>
       </p:sp>
       <p:sp>
         <p:nvSpPr>
@@ -2689,6 +2730,13 @@
           </a:solidFill>
           <a:ln/>
         </p:spPr>
+        <p:txBody>
+          <a:bodyPr/>
+          <a:lstStyle/>
+          <a:p>
+            <a:endParaRPr lang="en-US"/>
+          </a:p>
+        </p:txBody>
       </p:sp>
       <p:sp>
         <p:nvSpPr>
@@ -2711,7 +2759,7 @@
           <a:bodyPr wrap="square" rtlCol="0" anchor="ctr"/>
           <a:lstStyle/>
           <a:p>
-            <a:pPr algn="ctr" indent="0" marL="0">
+            <a:pPr marL="0" indent="0" algn="ctr">
               <a:buNone/>
             </a:pPr>
             <a:r>
@@ -2750,7 +2798,7 @@
           <a:bodyPr wrap="square" rtlCol="0" anchor="ctr"/>
           <a:lstStyle/>
           <a:p>
-            <a:pPr indent="0" marL="0">
+            <a:pPr marL="0" indent="0">
               <a:buNone/>
             </a:pPr>
             <a:r>
@@ -2789,7 +2837,7 @@
           <a:bodyPr wrap="square" rtlCol="0" anchor="t"/>
           <a:lstStyle/>
           <a:p>
-            <a:pPr indent="0" marL="0">
+            <a:pPr marL="0" indent="0">
               <a:buNone/>
             </a:pPr>
             <a:r>
@@ -2826,6 +2874,13 @@
           </a:solidFill>
           <a:ln/>
         </p:spPr>
+        <p:txBody>
+          <a:bodyPr/>
+          <a:lstStyle/>
+          <a:p>
+            <a:endParaRPr lang="en-US"/>
+          </a:p>
+        </p:txBody>
       </p:sp>
       <p:sp>
         <p:nvSpPr>
@@ -2846,6 +2901,13 @@
           </a:solidFill>
           <a:ln/>
         </p:spPr>
+        <p:txBody>
+          <a:bodyPr/>
+          <a:lstStyle/>
+          <a:p>
+            <a:endParaRPr lang="en-US"/>
+          </a:p>
+        </p:txBody>
       </p:sp>
       <p:sp>
         <p:nvSpPr>
@@ -2868,7 +2930,7 @@
           <a:bodyPr wrap="square" rtlCol="0" anchor="ctr"/>
           <a:lstStyle/>
           <a:p>
-            <a:pPr algn="ctr" indent="0" marL="0">
+            <a:pPr marL="0" indent="0" algn="ctr">
               <a:buNone/>
             </a:pPr>
             <a:r>
@@ -2907,7 +2969,7 @@
           <a:bodyPr wrap="square" rtlCol="0" anchor="ctr"/>
           <a:lstStyle/>
           <a:p>
-            <a:pPr indent="0" marL="0">
+            <a:pPr marL="0" indent="0">
               <a:buNone/>
             </a:pPr>
             <a:r>
@@ -2946,7 +3008,7 @@
           <a:bodyPr wrap="square" rtlCol="0" anchor="t"/>
           <a:lstStyle/>
           <a:p>
-            <a:pPr indent="0" marL="0">
+            <a:pPr marL="0" indent="0">
               <a:buNone/>
             </a:pPr>
             <a:r>
@@ -2983,6 +3045,13 @@
           </a:solidFill>
           <a:ln/>
         </p:spPr>
+        <p:txBody>
+          <a:bodyPr/>
+          <a:lstStyle/>
+          <a:p>
+            <a:endParaRPr lang="en-US"/>
+          </a:p>
+        </p:txBody>
       </p:sp>
       <p:sp>
         <p:nvSpPr>
@@ -3003,6 +3072,13 @@
           </a:solidFill>
           <a:ln/>
         </p:spPr>
+        <p:txBody>
+          <a:bodyPr/>
+          <a:lstStyle/>
+          <a:p>
+            <a:endParaRPr lang="en-US"/>
+          </a:p>
+        </p:txBody>
       </p:sp>
       <p:sp>
         <p:nvSpPr>
@@ -3025,7 +3101,7 @@
           <a:bodyPr wrap="square" rtlCol="0" anchor="ctr"/>
           <a:lstStyle/>
           <a:p>
-            <a:pPr algn="ctr" indent="0" marL="0">
+            <a:pPr marL="0" indent="0" algn="ctr">
               <a:buNone/>
             </a:pPr>
             <a:r>
@@ -3064,7 +3140,7 @@
           <a:bodyPr wrap="square" rtlCol="0" anchor="ctr"/>
           <a:lstStyle/>
           <a:p>
-            <a:pPr indent="0" marL="0">
+            <a:pPr marL="0" indent="0">
               <a:buNone/>
             </a:pPr>
             <a:r>
@@ -3103,7 +3179,7 @@
           <a:bodyPr wrap="square" rtlCol="0" anchor="t"/>
           <a:lstStyle/>
           <a:p>
-            <a:pPr indent="0" marL="0">
+            <a:pPr marL="0" indent="0">
               <a:buNone/>
             </a:pPr>
             <a:r>
@@ -3140,6 +3216,13 @@
           </a:solidFill>
           <a:ln/>
         </p:spPr>
+        <p:txBody>
+          <a:bodyPr/>
+          <a:lstStyle/>
+          <a:p>
+            <a:endParaRPr lang="en-US"/>
+          </a:p>
+        </p:txBody>
       </p:sp>
       <p:sp>
         <p:nvSpPr>
@@ -3160,6 +3243,13 @@
           </a:solidFill>
           <a:ln/>
         </p:spPr>
+        <p:txBody>
+          <a:bodyPr/>
+          <a:lstStyle/>
+          <a:p>
+            <a:endParaRPr lang="en-US"/>
+          </a:p>
+        </p:txBody>
       </p:sp>
       <p:sp>
         <p:nvSpPr>
@@ -3182,7 +3272,7 @@
           <a:bodyPr wrap="square" rtlCol="0" anchor="ctr"/>
           <a:lstStyle/>
           <a:p>
-            <a:pPr algn="ctr" indent="0" marL="0">
+            <a:pPr marL="0" indent="0" algn="ctr">
               <a:buNone/>
             </a:pPr>
             <a:r>
@@ -3221,7 +3311,7 @@
           <a:bodyPr wrap="square" rtlCol="0" anchor="ctr"/>
           <a:lstStyle/>
           <a:p>
-            <a:pPr indent="0" marL="0">
+            <a:pPr marL="0" indent="0">
               <a:buNone/>
             </a:pPr>
             <a:r>
@@ -3260,7 +3350,7 @@
           <a:bodyPr wrap="square" rtlCol="0" anchor="t"/>
           <a:lstStyle/>
           <a:p>
-            <a:pPr indent="0" marL="0">
+            <a:pPr marL="0" indent="0">
               <a:buNone/>
             </a:pPr>
             <a:r>
@@ -3299,7 +3389,7 @@
           <a:bodyPr wrap="square" rtlCol="0" anchor="ctr"/>
           <a:lstStyle/>
           <a:p>
-            <a:pPr indent="0" marL="0">
+            <a:pPr marL="0" indent="0">
               <a:buNone/>
             </a:pPr>
             <a:r>
@@ -3338,7 +3428,7 @@
           <a:bodyPr wrap="square" rtlCol="0" anchor="ctr"/>
           <a:lstStyle/>
           <a:p>
-            <a:pPr algn="r" indent="0" marL="0">
+            <a:pPr marL="0" indent="0" algn="r">
               <a:buNone/>
             </a:pPr>
             <a:r>
@@ -3364,7 +3454,7 @@
 </p:sld>
 </file>
 
-<file path=ppt/slides/slide12.xml><?xml version="1.0" encoding="utf-8"?>
+<file path=ppt/slides/slide13.xml><?xml version="1.0" encoding="utf-8"?>
 <p:sld xmlns:a="http://schemas.openxmlformats.org/drawingml/2006/main" xmlns:r="http://schemas.openxmlformats.org/officeDocument/2006/relationships" xmlns:p="http://schemas.openxmlformats.org/presentationml/2006/main">
   <p:cSld name="Slide 12">
     <p:spTree>
@@ -3400,6 +3490,13 @@
           </a:solidFill>
           <a:ln/>
         </p:spPr>
+        <p:txBody>
+          <a:bodyPr/>
+          <a:lstStyle/>
+          <a:p>
+            <a:endParaRPr lang="en-US"/>
+          </a:p>
+        </p:txBody>
       </p:sp>
       <p:sp>
         <p:nvSpPr>
@@ -3422,7 +3519,7 @@
           <a:bodyPr wrap="square" rtlCol="0" anchor="ctr"/>
           <a:lstStyle/>
           <a:p>
-            <a:pPr indent="0" marL="0">
+            <a:pPr marL="0" indent="0">
               <a:buNone/>
             </a:pPr>
             <a:r>
@@ -3461,7 +3558,7 @@
           <a:bodyPr wrap="square" rtlCol="0" anchor="ctr"/>
           <a:lstStyle/>
           <a:p>
-            <a:pPr indent="0" marL="0">
+            <a:pPr marL="0" indent="0">
               <a:buNone/>
             </a:pPr>
             <a:r>
@@ -3500,9 +3597,6 @@
           <a:bodyPr wrap="square" rtlCol="0" anchor="ctr"/>
           <a:lstStyle/>
           <a:p>
-            <a:pPr indent="0" marL="0">
-              <a:buNone/>
-            </a:pPr>
             <a:r>
               <a:rPr lang="en-US" sz="1500" b="1" dirty="0">
                 <a:solidFill>
@@ -3512,7 +3606,7 @@
                 <a:ea typeface="Calibri" pitchFamily="34" charset="-122"/>
                 <a:cs typeface="Calibri" pitchFamily="34" charset="-120"/>
               </a:rPr>
-              <a:t>Janna Haleema</a:t>
+              <a:t>Haleema Janna</a:t>
             </a:r>
             <a:endParaRPr lang="en-US" sz="1500" dirty="0"/>
           </a:p>
@@ -3539,7 +3633,7 @@
           <a:bodyPr wrap="square" rtlCol="0" anchor="ctr"/>
           <a:lstStyle/>
           <a:p>
-            <a:pPr indent="0" marL="0">
+            <a:pPr marL="0" indent="0">
               <a:buNone/>
             </a:pPr>
             <a:r>
@@ -3603,7 +3697,7 @@
           <a:bodyPr wrap="square" rtlCol="0" anchor="ctr"/>
           <a:lstStyle/>
           <a:p>
-            <a:pPr indent="0" marL="0">
+            <a:pPr marL="0" indent="0">
               <a:buNone/>
             </a:pPr>
             <a:r>
@@ -3640,6 +3734,13 @@
           </a:solidFill>
           <a:ln/>
         </p:spPr>
+        <p:txBody>
+          <a:bodyPr/>
+          <a:lstStyle/>
+          <a:p>
+            <a:endParaRPr lang="en-US"/>
+          </a:p>
+        </p:txBody>
       </p:sp>
       <p:sp>
         <p:nvSpPr>
@@ -3662,7 +3763,7 @@
           <a:bodyPr wrap="square" rtlCol="0" anchor="ctr"/>
           <a:lstStyle/>
           <a:p>
-            <a:pPr indent="0" marL="0">
+            <a:pPr marL="0" indent="0">
               <a:buNone/>
             </a:pPr>
             <a:r>
@@ -3701,7 +3802,7 @@
           <a:bodyPr wrap="square" rtlCol="0" anchor="ctr"/>
           <a:lstStyle/>
           <a:p>
-            <a:pPr indent="0" marL="0">
+            <a:pPr marL="0" indent="0">
               <a:lnSpc>
                 <a:spcPct val="130000"/>
               </a:lnSpc>
@@ -3741,6 +3842,13 @@
           </a:solidFill>
           <a:ln/>
         </p:spPr>
+        <p:txBody>
+          <a:bodyPr/>
+          <a:lstStyle/>
+          <a:p>
+            <a:endParaRPr lang="en-US"/>
+          </a:p>
+        </p:txBody>
       </p:sp>
       <p:sp>
         <p:nvSpPr>
@@ -3763,7 +3871,7 @@
           <a:bodyPr wrap="square" rtlCol="0" anchor="ctr"/>
           <a:lstStyle/>
           <a:p>
-            <a:pPr indent="0" marL="0">
+            <a:pPr marL="0" indent="0">
               <a:buNone/>
             </a:pPr>
             <a:r>
@@ -3908,7 +4016,7 @@
           <a:bodyPr wrap="square" rtlCol="0" anchor="ctr"/>
           <a:lstStyle/>
           <a:p>
-            <a:pPr indent="0" marL="0">
+            <a:pPr marL="0" indent="0">
               <a:buNone/>
             </a:pPr>
             <a:r>
@@ -3947,7 +4055,7 @@
           <a:bodyPr wrap="square" rtlCol="0" anchor="ctr"/>
           <a:lstStyle/>
           <a:p>
-            <a:pPr algn="r" indent="0" marL="0">
+            <a:pPr marL="0" indent="0" algn="r">
               <a:buNone/>
             </a:pPr>
             <a:r>
@@ -4011,7 +4119,7 @@
           <a:bodyPr wrap="square" rtlCol="0" anchor="ctr"/>
           <a:lstStyle/>
           <a:p>
-            <a:pPr indent="0" marL="0">
+            <a:pPr marL="0" indent="0">
               <a:buNone/>
             </a:pPr>
             <a:r>
@@ -4050,7 +4158,7 @@
           <a:bodyPr wrap="square" rtlCol="0" anchor="ctr"/>
           <a:lstStyle/>
           <a:p>
-            <a:pPr indent="0" marL="0">
+            <a:pPr marL="0" indent="0">
               <a:buNone/>
             </a:pPr>
             <a:r>
@@ -4084,16 +4192,34 @@
         </p:nvGraphicFramePr>
         <p:xfrm>
           <a:off x="548640" y="1600200"/>
-          <a:ext cx="11064240" cy="4297680"/>
+          <a:ext cx="11064240" cy="4389120"/>
         </p:xfrm>
         <a:graphic>
           <a:graphicData uri="http://schemas.openxmlformats.org/drawingml/2006/table">
             <a:tbl>
               <a:tblPr/>
               <a:tblGrid>
-                <a:gridCol w="3840480"/>
-                <a:gridCol w="5852160"/>
-                <a:gridCol w="1371600"/>
+                <a:gridCol w="3840480">
+                  <a:extLst>
+                    <a:ext uri="{9D8B030D-6E8A-4147-A177-3AD203B41FA5}">
+                      <a16:colId xmlns:a16="http://schemas.microsoft.com/office/drawing/2014/main" val="20000"/>
+                    </a:ext>
+                  </a:extLst>
+                </a:gridCol>
+                <a:gridCol w="5852160">
+                  <a:extLst>
+                    <a:ext uri="{9D8B030D-6E8A-4147-A177-3AD203B41FA5}">
+                      <a16:colId xmlns:a16="http://schemas.microsoft.com/office/drawing/2014/main" val="20001"/>
+                    </a:ext>
+                  </a:extLst>
+                </a:gridCol>
+                <a:gridCol w="1371600">
+                  <a:extLst>
+                    <a:ext uri="{9D8B030D-6E8A-4147-A177-3AD203B41FA5}">
+                      <a16:colId xmlns:a16="http://schemas.microsoft.com/office/drawing/2014/main" val="20002"/>
+                    </a:ext>
+                  </a:extLst>
+                </a:gridCol>
               </a:tblGrid>
               <a:tr h="548640">
                 <a:tc>
@@ -4101,7 +4227,7 @@
                     <a:bodyPr/>
                     <a:lstStyle/>
                     <a:p>
-                      <a:pPr algn="l" indent="0" marL="0">
+                      <a:pPr marL="0" indent="0" algn="l">
                         <a:buNone/>
                       </a:pPr>
                       <a:r>
@@ -4122,7 +4248,7 @@
                       </a:endParaRPr>
                     </a:p>
                   </a:txBody>
-                  <a:tcPr marL="91440" marR="91440" marT="45720" marB="45720" anchor="ctr">
+                  <a:tcPr anchor="ctr">
                     <a:lnL w="6350" cap="flat" cmpd="sng" algn="ctr">
                       <a:solidFill>
                         <a:srgbClr val="E0DCEC"/>
@@ -4169,7 +4295,7 @@
                     <a:bodyPr/>
                     <a:lstStyle/>
                     <a:p>
-                      <a:pPr algn="l" indent="0" marL="0">
+                      <a:pPr marL="0" indent="0" algn="l">
                         <a:buNone/>
                       </a:pPr>
                       <a:r>
@@ -4190,7 +4316,7 @@
                       </a:endParaRPr>
                     </a:p>
                   </a:txBody>
-                  <a:tcPr marL="91440" marR="91440" marT="45720" marB="45720" anchor="ctr">
+                  <a:tcPr anchor="ctr">
                     <a:lnL w="6350" cap="flat" cmpd="sng" algn="ctr">
                       <a:solidFill>
                         <a:srgbClr val="E0DCEC"/>
@@ -4237,7 +4363,7 @@
                     <a:bodyPr/>
                     <a:lstStyle/>
                     <a:p>
-                      <a:pPr algn="r" indent="0" marL="0">
+                      <a:pPr marL="0" indent="0" algn="r">
                         <a:buNone/>
                       </a:pPr>
                       <a:r>
@@ -4258,7 +4384,7 @@
                       </a:endParaRPr>
                     </a:p>
                   </a:txBody>
-                  <a:tcPr marL="91440" marR="91440" marT="45720" marB="45720" anchor="ctr">
+                  <a:tcPr anchor="ctr">
                     <a:lnL w="6350" cap="flat" cmpd="sng" algn="ctr">
                       <a:solidFill>
                         <a:srgbClr val="E0DCEC"/>
@@ -4300,6 +4426,11 @@
                     </a:solidFill>
                   </a:tcPr>
                 </a:tc>
+                <a:extLst>
+                  <a:ext uri="{0D108BD9-81ED-4DB2-BD59-A6C34878D82A}">
+                    <a16:rowId xmlns:a16="http://schemas.microsoft.com/office/drawing/2014/main" val="10000"/>
+                  </a:ext>
+                </a:extLst>
               </a:tr>
               <a:tr h="548640">
                 <a:tc>
@@ -4307,7 +4438,7 @@
                     <a:bodyPr/>
                     <a:lstStyle/>
                     <a:p>
-                      <a:pPr algn="l" indent="0" marL="0">
+                      <a:pPr marL="0" indent="0" algn="l">
                         <a:buNone/>
                       </a:pPr>
                       <a:r>
@@ -4328,7 +4459,7 @@
                       </a:endParaRPr>
                     </a:p>
                   </a:txBody>
-                  <a:tcPr marL="91440" marR="91440" marT="45720" marB="45720" anchor="ctr">
+                  <a:tcPr anchor="ctr">
                     <a:lnL w="6350" cap="flat" cmpd="sng" algn="ctr">
                       <a:solidFill>
                         <a:srgbClr val="E0DCEC"/>
@@ -4375,7 +4506,7 @@
                     <a:bodyPr/>
                     <a:lstStyle/>
                     <a:p>
-                      <a:pPr algn="l" indent="0" marL="0">
+                      <a:pPr marL="0" indent="0" algn="l">
                         <a:buNone/>
                       </a:pPr>
                       <a:r>
@@ -4396,7 +4527,7 @@
                       </a:endParaRPr>
                     </a:p>
                   </a:txBody>
-                  <a:tcPr marL="91440" marR="91440" marT="45720" marB="45720" anchor="ctr">
+                  <a:tcPr anchor="ctr">
                     <a:lnL w="6350" cap="flat" cmpd="sng" algn="ctr">
                       <a:solidFill>
                         <a:srgbClr val="E0DCEC"/>
@@ -4443,7 +4574,7 @@
                     <a:bodyPr/>
                     <a:lstStyle/>
                     <a:p>
-                      <a:pPr algn="r" indent="0" marL="0">
+                      <a:pPr marL="0" indent="0" algn="r">
                         <a:buNone/>
                       </a:pPr>
                       <a:r>
@@ -4464,7 +4595,7 @@
                       </a:endParaRPr>
                     </a:p>
                   </a:txBody>
-                  <a:tcPr marL="91440" marR="91440" marT="45720" marB="45720" anchor="ctr">
+                  <a:tcPr anchor="ctr">
                     <a:lnL w="6350" cap="flat" cmpd="sng" algn="ctr">
                       <a:solidFill>
                         <a:srgbClr val="E0DCEC"/>
@@ -4506,6 +4637,11 @@
                     </a:solidFill>
                   </a:tcPr>
                 </a:tc>
+                <a:extLst>
+                  <a:ext uri="{0D108BD9-81ED-4DB2-BD59-A6C34878D82A}">
+                    <a16:rowId xmlns:a16="http://schemas.microsoft.com/office/drawing/2014/main" val="10001"/>
+                  </a:ext>
+                </a:extLst>
               </a:tr>
               <a:tr h="548640">
                 <a:tc>
@@ -4513,7 +4649,7 @@
                     <a:bodyPr/>
                     <a:lstStyle/>
                     <a:p>
-                      <a:pPr algn="l" indent="0" marL="0">
+                      <a:pPr marL="0" indent="0" algn="l">
                         <a:buNone/>
                       </a:pPr>
                       <a:r>
@@ -4534,7 +4670,7 @@
                       </a:endParaRPr>
                     </a:p>
                   </a:txBody>
-                  <a:tcPr marL="91440" marR="91440" marT="45720" marB="45720" anchor="ctr">
+                  <a:tcPr anchor="ctr">
                     <a:lnL w="6350" cap="flat" cmpd="sng" algn="ctr">
                       <a:solidFill>
                         <a:srgbClr val="E0DCEC"/>
@@ -4581,7 +4717,7 @@
                     <a:bodyPr/>
                     <a:lstStyle/>
                     <a:p>
-                      <a:pPr algn="l" indent="0" marL="0">
+                      <a:pPr marL="0" indent="0" algn="l">
                         <a:buNone/>
                       </a:pPr>
                       <a:r>
@@ -4602,7 +4738,7 @@
                       </a:endParaRPr>
                     </a:p>
                   </a:txBody>
-                  <a:tcPr marL="91440" marR="91440" marT="45720" marB="45720" anchor="ctr">
+                  <a:tcPr anchor="ctr">
                     <a:lnL w="6350" cap="flat" cmpd="sng" algn="ctr">
                       <a:solidFill>
                         <a:srgbClr val="E0DCEC"/>
@@ -4649,7 +4785,7 @@
                     <a:bodyPr/>
                     <a:lstStyle/>
                     <a:p>
-                      <a:pPr algn="r" indent="0" marL="0">
+                      <a:pPr marL="0" indent="0" algn="r">
                         <a:buNone/>
                       </a:pPr>
                       <a:r>
@@ -4670,7 +4806,7 @@
                       </a:endParaRPr>
                     </a:p>
                   </a:txBody>
-                  <a:tcPr marL="91440" marR="91440" marT="45720" marB="45720" anchor="ctr">
+                  <a:tcPr anchor="ctr">
                     <a:lnL w="6350" cap="flat" cmpd="sng" algn="ctr">
                       <a:solidFill>
                         <a:srgbClr val="E0DCEC"/>
@@ -4712,6 +4848,11 @@
                     </a:solidFill>
                   </a:tcPr>
                 </a:tc>
+                <a:extLst>
+                  <a:ext uri="{0D108BD9-81ED-4DB2-BD59-A6C34878D82A}">
+                    <a16:rowId xmlns:a16="http://schemas.microsoft.com/office/drawing/2014/main" val="10002"/>
+                  </a:ext>
+                </a:extLst>
               </a:tr>
               <a:tr h="548640">
                 <a:tc>
@@ -4719,7 +4860,7 @@
                     <a:bodyPr/>
                     <a:lstStyle/>
                     <a:p>
-                      <a:pPr algn="l" indent="0" marL="0">
+                      <a:pPr marL="0" indent="0" algn="l">
                         <a:buNone/>
                       </a:pPr>
                       <a:r>
@@ -4740,7 +4881,7 @@
                       </a:endParaRPr>
                     </a:p>
                   </a:txBody>
-                  <a:tcPr marL="91440" marR="91440" marT="45720" marB="45720" anchor="ctr">
+                  <a:tcPr anchor="ctr">
                     <a:lnL w="6350" cap="flat" cmpd="sng" algn="ctr">
                       <a:solidFill>
                         <a:srgbClr val="E0DCEC"/>
@@ -4787,7 +4928,7 @@
                     <a:bodyPr/>
                     <a:lstStyle/>
                     <a:p>
-                      <a:pPr algn="l" indent="0" marL="0">
+                      <a:pPr marL="0" indent="0" algn="l">
                         <a:buNone/>
                       </a:pPr>
                       <a:r>
@@ -4808,7 +4949,7 @@
                       </a:endParaRPr>
                     </a:p>
                   </a:txBody>
-                  <a:tcPr marL="91440" marR="91440" marT="45720" marB="45720" anchor="ctr">
+                  <a:tcPr anchor="ctr">
                     <a:lnL w="6350" cap="flat" cmpd="sng" algn="ctr">
                       <a:solidFill>
                         <a:srgbClr val="E0DCEC"/>
@@ -4855,7 +4996,7 @@
                     <a:bodyPr/>
                     <a:lstStyle/>
                     <a:p>
-                      <a:pPr algn="r" indent="0" marL="0">
+                      <a:pPr marL="0" indent="0" algn="r">
                         <a:buNone/>
                       </a:pPr>
                       <a:r>
@@ -4876,7 +5017,7 @@
                       </a:endParaRPr>
                     </a:p>
                   </a:txBody>
-                  <a:tcPr marL="91440" marR="91440" marT="45720" marB="45720" anchor="ctr">
+                  <a:tcPr anchor="ctr">
                     <a:lnL w="6350" cap="flat" cmpd="sng" algn="ctr">
                       <a:solidFill>
                         <a:srgbClr val="E0DCEC"/>
@@ -4918,6 +5059,11 @@
                     </a:solidFill>
                   </a:tcPr>
                 </a:tc>
+                <a:extLst>
+                  <a:ext uri="{0D108BD9-81ED-4DB2-BD59-A6C34878D82A}">
+                    <a16:rowId xmlns:a16="http://schemas.microsoft.com/office/drawing/2014/main" val="10003"/>
+                  </a:ext>
+                </a:extLst>
               </a:tr>
               <a:tr h="548640">
                 <a:tc>
@@ -4925,7 +5071,7 @@
                     <a:bodyPr/>
                     <a:lstStyle/>
                     <a:p>
-                      <a:pPr algn="l" indent="0" marL="0">
+                      <a:pPr marL="0" indent="0" algn="l">
                         <a:buNone/>
                       </a:pPr>
                       <a:r>
@@ -4946,7 +5092,7 @@
                       </a:endParaRPr>
                     </a:p>
                   </a:txBody>
-                  <a:tcPr marL="91440" marR="91440" marT="45720" marB="45720" anchor="ctr">
+                  <a:tcPr anchor="ctr">
                     <a:lnL w="6350" cap="flat" cmpd="sng" algn="ctr">
                       <a:solidFill>
                         <a:srgbClr val="E0DCEC"/>
@@ -4993,7 +5139,7 @@
                     <a:bodyPr/>
                     <a:lstStyle/>
                     <a:p>
-                      <a:pPr algn="l" indent="0" marL="0">
+                      <a:pPr marL="0" indent="0" algn="l">
                         <a:buNone/>
                       </a:pPr>
                       <a:r>
@@ -5014,7 +5160,7 @@
                       </a:endParaRPr>
                     </a:p>
                   </a:txBody>
-                  <a:tcPr marL="91440" marR="91440" marT="45720" marB="45720" anchor="ctr">
+                  <a:tcPr anchor="ctr">
                     <a:lnL w="6350" cap="flat" cmpd="sng" algn="ctr">
                       <a:solidFill>
                         <a:srgbClr val="E0DCEC"/>
@@ -5061,7 +5207,7 @@
                     <a:bodyPr/>
                     <a:lstStyle/>
                     <a:p>
-                      <a:pPr algn="r" indent="0" marL="0">
+                      <a:pPr marL="0" indent="0" algn="r">
                         <a:buNone/>
                       </a:pPr>
                       <a:r>
@@ -5082,7 +5228,7 @@
                       </a:endParaRPr>
                     </a:p>
                   </a:txBody>
-                  <a:tcPr marL="91440" marR="91440" marT="45720" marB="45720" anchor="ctr">
+                  <a:tcPr anchor="ctr">
                     <a:lnL w="6350" cap="flat" cmpd="sng" algn="ctr">
                       <a:solidFill>
                         <a:srgbClr val="E0DCEC"/>
@@ -5124,6 +5270,11 @@
                     </a:solidFill>
                   </a:tcPr>
                 </a:tc>
+                <a:extLst>
+                  <a:ext uri="{0D108BD9-81ED-4DB2-BD59-A6C34878D82A}">
+                    <a16:rowId xmlns:a16="http://schemas.microsoft.com/office/drawing/2014/main" val="10004"/>
+                  </a:ext>
+                </a:extLst>
               </a:tr>
               <a:tr h="548640">
                 <a:tc>
@@ -5131,7 +5282,7 @@
                     <a:bodyPr/>
                     <a:lstStyle/>
                     <a:p>
-                      <a:pPr algn="l" indent="0" marL="0">
+                      <a:pPr marL="0" indent="0" algn="l">
                         <a:buNone/>
                       </a:pPr>
                       <a:r>
@@ -5152,7 +5303,7 @@
                       </a:endParaRPr>
                     </a:p>
                   </a:txBody>
-                  <a:tcPr marL="91440" marR="91440" marT="45720" marB="45720" anchor="ctr">
+                  <a:tcPr anchor="ctr">
                     <a:lnL w="6350" cap="flat" cmpd="sng" algn="ctr">
                       <a:solidFill>
                         <a:srgbClr val="E0DCEC"/>
@@ -5199,7 +5350,7 @@
                     <a:bodyPr/>
                     <a:lstStyle/>
                     <a:p>
-                      <a:pPr algn="l" indent="0" marL="0">
+                      <a:pPr marL="0" indent="0" algn="l">
                         <a:buNone/>
                       </a:pPr>
                       <a:r>
@@ -5220,7 +5371,7 @@
                       </a:endParaRPr>
                     </a:p>
                   </a:txBody>
-                  <a:tcPr marL="91440" marR="91440" marT="45720" marB="45720" anchor="ctr">
+                  <a:tcPr anchor="ctr">
                     <a:lnL w="6350" cap="flat" cmpd="sng" algn="ctr">
                       <a:solidFill>
                         <a:srgbClr val="E0DCEC"/>
@@ -5267,7 +5418,7 @@
                     <a:bodyPr/>
                     <a:lstStyle/>
                     <a:p>
-                      <a:pPr algn="r" indent="0" marL="0">
+                      <a:pPr marL="0" indent="0" algn="r">
                         <a:buNone/>
                       </a:pPr>
                       <a:r>
@@ -5288,7 +5439,7 @@
                       </a:endParaRPr>
                     </a:p>
                   </a:txBody>
-                  <a:tcPr marL="91440" marR="91440" marT="45720" marB="45720" anchor="ctr">
+                  <a:tcPr anchor="ctr">
                     <a:lnL w="6350" cap="flat" cmpd="sng" algn="ctr">
                       <a:solidFill>
                         <a:srgbClr val="E0DCEC"/>
@@ -5330,6 +5481,11 @@
                     </a:solidFill>
                   </a:tcPr>
                 </a:tc>
+                <a:extLst>
+                  <a:ext uri="{0D108BD9-81ED-4DB2-BD59-A6C34878D82A}">
+                    <a16:rowId xmlns:a16="http://schemas.microsoft.com/office/drawing/2014/main" val="10005"/>
+                  </a:ext>
+                </a:extLst>
               </a:tr>
               <a:tr h="548640">
                 <a:tc>
@@ -5337,7 +5493,7 @@
                     <a:bodyPr/>
                     <a:lstStyle/>
                     <a:p>
-                      <a:pPr algn="l" indent="0" marL="0">
+                      <a:pPr marL="0" indent="0" algn="l">
                         <a:buNone/>
                       </a:pPr>
                       <a:r>
@@ -5358,7 +5514,7 @@
                       </a:endParaRPr>
                     </a:p>
                   </a:txBody>
-                  <a:tcPr marL="91440" marR="91440" marT="45720" marB="45720" anchor="ctr">
+                  <a:tcPr anchor="ctr">
                     <a:lnL w="6350" cap="flat" cmpd="sng" algn="ctr">
                       <a:solidFill>
                         <a:srgbClr val="E0DCEC"/>
@@ -5405,7 +5561,7 @@
                     <a:bodyPr/>
                     <a:lstStyle/>
                     <a:p>
-                      <a:pPr algn="l" indent="0" marL="0">
+                      <a:pPr marL="0" indent="0" algn="l">
                         <a:buNone/>
                       </a:pPr>
                       <a:r>
@@ -5426,7 +5582,7 @@
                       </a:endParaRPr>
                     </a:p>
                   </a:txBody>
-                  <a:tcPr marL="91440" marR="91440" marT="45720" marB="45720" anchor="ctr">
+                  <a:tcPr anchor="ctr">
                     <a:lnL w="6350" cap="flat" cmpd="sng" algn="ctr">
                       <a:solidFill>
                         <a:srgbClr val="E0DCEC"/>
@@ -5473,7 +5629,7 @@
                     <a:bodyPr/>
                     <a:lstStyle/>
                     <a:p>
-                      <a:pPr algn="r" indent="0" marL="0">
+                      <a:pPr marL="0" indent="0" algn="r">
                         <a:buNone/>
                       </a:pPr>
                       <a:r>
@@ -5494,7 +5650,7 @@
                       </a:endParaRPr>
                     </a:p>
                   </a:txBody>
-                  <a:tcPr marL="91440" marR="91440" marT="45720" marB="45720" anchor="ctr">
+                  <a:tcPr anchor="ctr">
                     <a:lnL w="6350" cap="flat" cmpd="sng" algn="ctr">
                       <a:solidFill>
                         <a:srgbClr val="E0DCEC"/>
@@ -5536,6 +5692,11 @@
                     </a:solidFill>
                   </a:tcPr>
                 </a:tc>
+                <a:extLst>
+                  <a:ext uri="{0D108BD9-81ED-4DB2-BD59-A6C34878D82A}">
+                    <a16:rowId xmlns:a16="http://schemas.microsoft.com/office/drawing/2014/main" val="10006"/>
+                  </a:ext>
+                </a:extLst>
               </a:tr>
               <a:tr h="548640">
                 <a:tc>
@@ -5543,7 +5704,7 @@
                     <a:bodyPr/>
                     <a:lstStyle/>
                     <a:p>
-                      <a:pPr algn="l" indent="0" marL="0">
+                      <a:pPr marL="0" indent="0" algn="l">
                         <a:buNone/>
                       </a:pPr>
                       <a:r>
@@ -5564,7 +5725,7 @@
                       </a:endParaRPr>
                     </a:p>
                   </a:txBody>
-                  <a:tcPr marL="91440" marR="91440" marT="45720" marB="45720" anchor="ctr">
+                  <a:tcPr anchor="ctr">
                     <a:lnL w="6350" cap="flat" cmpd="sng" algn="ctr">
                       <a:solidFill>
                         <a:srgbClr val="E0DCEC"/>
@@ -5611,7 +5772,7 @@
                     <a:bodyPr/>
                     <a:lstStyle/>
                     <a:p>
-                      <a:pPr algn="l" indent="0" marL="0">
+                      <a:pPr marL="0" indent="0" algn="l">
                         <a:buNone/>
                       </a:pPr>
                       <a:r>
@@ -5632,7 +5793,7 @@
                       </a:endParaRPr>
                     </a:p>
                   </a:txBody>
-                  <a:tcPr marL="91440" marR="91440" marT="45720" marB="45720" anchor="ctr">
+                  <a:tcPr anchor="ctr">
                     <a:lnL w="6350" cap="flat" cmpd="sng" algn="ctr">
                       <a:solidFill>
                         <a:srgbClr val="E0DCEC"/>
@@ -5679,7 +5840,7 @@
                     <a:bodyPr/>
                     <a:lstStyle/>
                     <a:p>
-                      <a:pPr algn="r" indent="0" marL="0">
+                      <a:pPr marL="0" indent="0" algn="r">
                         <a:buNone/>
                       </a:pPr>
                       <a:r>
@@ -5700,7 +5861,7 @@
                       </a:endParaRPr>
                     </a:p>
                   </a:txBody>
-                  <a:tcPr marL="91440" marR="91440" marT="45720" marB="45720" anchor="ctr">
+                  <a:tcPr anchor="ctr">
                     <a:lnL w="6350" cap="flat" cmpd="sng" algn="ctr">
                       <a:solidFill>
                         <a:srgbClr val="E0DCEC"/>
@@ -5742,6 +5903,11 @@
                     </a:solidFill>
                   </a:tcPr>
                 </a:tc>
+                <a:extLst>
+                  <a:ext uri="{0D108BD9-81ED-4DB2-BD59-A6C34878D82A}">
+                    <a16:rowId xmlns:a16="http://schemas.microsoft.com/office/drawing/2014/main" val="10007"/>
+                  </a:ext>
+                </a:extLst>
               </a:tr>
             </a:tbl>
           </a:graphicData>
@@ -5768,7 +5934,7 @@
           <a:bodyPr wrap="square" rtlCol="0" anchor="ctr"/>
           <a:lstStyle/>
           <a:p>
-            <a:pPr indent="0" marL="0">
+            <a:pPr marL="0" indent="0">
               <a:buNone/>
             </a:pPr>
             <a:r>
@@ -5807,7 +5973,7 @@
           <a:bodyPr wrap="square" rtlCol="0" anchor="ctr"/>
           <a:lstStyle/>
           <a:p>
-            <a:pPr indent="0" marL="0">
+            <a:pPr marL="0" indent="0">
               <a:buNone/>
             </a:pPr>
             <a:r>
@@ -5846,7 +6012,7 @@
           <a:bodyPr wrap="square" rtlCol="0" anchor="ctr"/>
           <a:lstStyle/>
           <a:p>
-            <a:pPr algn="r" indent="0" marL="0">
+            <a:pPr marL="0" indent="0" algn="r">
               <a:buNone/>
             </a:pPr>
             <a:r>
@@ -5910,7 +6076,7 @@
           <a:bodyPr wrap="square" rtlCol="0" anchor="ctr"/>
           <a:lstStyle/>
           <a:p>
-            <a:pPr indent="0" marL="0">
+            <a:pPr marL="0" indent="0">
               <a:buNone/>
             </a:pPr>
             <a:r>
@@ -5949,6 +6115,13 @@
           </a:solidFill>
           <a:ln/>
         </p:spPr>
+        <p:txBody>
+          <a:bodyPr/>
+          <a:lstStyle/>
+          <a:p>
+            <a:endParaRPr lang="en-US"/>
+          </a:p>
+        </p:txBody>
       </p:sp>
       <p:sp>
         <p:nvSpPr>
@@ -5971,7 +6144,7 @@
           <a:bodyPr wrap="square" rtlCol="0" anchor="ctr"/>
           <a:lstStyle/>
           <a:p>
-            <a:pPr indent="0" marL="0">
+            <a:pPr marL="0" indent="0">
               <a:buNone/>
             </a:pPr>
             <a:r>
@@ -6010,7 +6183,7 @@
           <a:bodyPr wrap="square" rtlCol="0" anchor="ctr"/>
           <a:lstStyle/>
           <a:p>
-            <a:pPr indent="0" marL="0">
+            <a:pPr marL="0" indent="0">
               <a:lnSpc>
                 <a:spcPct val="125000"/>
               </a:lnSpc>
@@ -6030,7 +6203,7 @@
             <a:endParaRPr lang="en-US" sz="1100" dirty="0"/>
           </a:p>
           <a:p>
-            <a:pPr indent="0" marL="0">
+            <a:pPr marL="0" indent="0">
               <a:lnSpc>
                 <a:spcPct val="125000"/>
               </a:lnSpc>
@@ -6050,7 +6223,7 @@
             <a:endParaRPr lang="en-US" sz="1100" dirty="0"/>
           </a:p>
           <a:p>
-            <a:pPr indent="0" marL="0">
+            <a:pPr marL="0" indent="0">
               <a:lnSpc>
                 <a:spcPct val="125000"/>
               </a:lnSpc>
@@ -6094,6 +6267,13 @@
             <a:tailEnd type="triangle"/>
           </a:ln>
         </p:spPr>
+        <p:txBody>
+          <a:bodyPr/>
+          <a:lstStyle/>
+          <a:p>
+            <a:endParaRPr lang="en-US"/>
+          </a:p>
+        </p:txBody>
       </p:sp>
       <p:sp>
         <p:nvSpPr>
@@ -6116,6 +6296,13 @@
           </a:solidFill>
           <a:ln/>
         </p:spPr>
+        <p:txBody>
+          <a:bodyPr/>
+          <a:lstStyle/>
+          <a:p>
+            <a:endParaRPr lang="en-US"/>
+          </a:p>
+        </p:txBody>
       </p:sp>
       <p:sp>
         <p:nvSpPr>
@@ -6138,7 +6325,7 @@
           <a:bodyPr wrap="square" rtlCol="0" anchor="ctr"/>
           <a:lstStyle/>
           <a:p>
-            <a:pPr indent="0" marL="0">
+            <a:pPr marL="0" indent="0">
               <a:buNone/>
             </a:pPr>
             <a:r>
@@ -6177,7 +6364,7 @@
           <a:bodyPr wrap="square" rtlCol="0" anchor="ctr"/>
           <a:lstStyle/>
           <a:p>
-            <a:pPr indent="0" marL="0">
+            <a:pPr marL="0" indent="0">
               <a:lnSpc>
                 <a:spcPct val="125000"/>
               </a:lnSpc>
@@ -6197,7 +6384,7 @@
             <a:endParaRPr lang="en-US" sz="1100" dirty="0"/>
           </a:p>
           <a:p>
-            <a:pPr indent="0" marL="0">
+            <a:pPr marL="0" indent="0">
               <a:lnSpc>
                 <a:spcPct val="125000"/>
               </a:lnSpc>
@@ -6217,7 +6404,7 @@
             <a:endParaRPr lang="en-US" sz="1100" dirty="0"/>
           </a:p>
           <a:p>
-            <a:pPr indent="0" marL="0">
+            <a:pPr marL="0" indent="0">
               <a:lnSpc>
                 <a:spcPct val="125000"/>
               </a:lnSpc>
@@ -6261,6 +6448,13 @@
             <a:tailEnd type="triangle"/>
           </a:ln>
         </p:spPr>
+        <p:txBody>
+          <a:bodyPr/>
+          <a:lstStyle/>
+          <a:p>
+            <a:endParaRPr lang="en-US"/>
+          </a:p>
+        </p:txBody>
       </p:sp>
       <p:sp>
         <p:nvSpPr>
@@ -6283,6 +6477,13 @@
           </a:solidFill>
           <a:ln/>
         </p:spPr>
+        <p:txBody>
+          <a:bodyPr/>
+          <a:lstStyle/>
+          <a:p>
+            <a:endParaRPr lang="en-US"/>
+          </a:p>
+        </p:txBody>
       </p:sp>
       <p:sp>
         <p:nvSpPr>
@@ -6305,7 +6506,7 @@
           <a:bodyPr wrap="square" rtlCol="0" anchor="ctr"/>
           <a:lstStyle/>
           <a:p>
-            <a:pPr indent="0" marL="0">
+            <a:pPr marL="0" indent="0">
               <a:buNone/>
             </a:pPr>
             <a:r>
@@ -6344,7 +6545,7 @@
           <a:bodyPr wrap="square" rtlCol="0" anchor="ctr"/>
           <a:lstStyle/>
           <a:p>
-            <a:pPr indent="0" marL="0">
+            <a:pPr marL="0" indent="0">
               <a:lnSpc>
                 <a:spcPct val="125000"/>
               </a:lnSpc>
@@ -6364,7 +6565,7 @@
             <a:endParaRPr lang="en-US" sz="1100" dirty="0"/>
           </a:p>
           <a:p>
-            <a:pPr indent="0" marL="0">
+            <a:pPr marL="0" indent="0">
               <a:lnSpc>
                 <a:spcPct val="125000"/>
               </a:lnSpc>
@@ -6384,7 +6585,7 @@
             <a:endParaRPr lang="en-US" sz="1100" dirty="0"/>
           </a:p>
           <a:p>
-            <a:pPr indent="0" marL="0">
+            <a:pPr marL="0" indent="0">
               <a:lnSpc>
                 <a:spcPct val="125000"/>
               </a:lnSpc>
@@ -6428,6 +6629,13 @@
             <a:tailEnd type="triangle"/>
           </a:ln>
         </p:spPr>
+        <p:txBody>
+          <a:bodyPr/>
+          <a:lstStyle/>
+          <a:p>
+            <a:endParaRPr lang="en-US"/>
+          </a:p>
+        </p:txBody>
       </p:sp>
       <p:sp>
         <p:nvSpPr>
@@ -6450,6 +6658,13 @@
           </a:solidFill>
           <a:ln/>
         </p:spPr>
+        <p:txBody>
+          <a:bodyPr/>
+          <a:lstStyle/>
+          <a:p>
+            <a:endParaRPr lang="en-US"/>
+          </a:p>
+        </p:txBody>
       </p:sp>
       <p:sp>
         <p:nvSpPr>
@@ -6472,7 +6687,7 @@
           <a:bodyPr wrap="square" rtlCol="0" anchor="ctr"/>
           <a:lstStyle/>
           <a:p>
-            <a:pPr indent="0" marL="0">
+            <a:pPr marL="0" indent="0">
               <a:buNone/>
             </a:pPr>
             <a:r>
@@ -6511,7 +6726,7 @@
           <a:bodyPr wrap="square" rtlCol="0" anchor="ctr"/>
           <a:lstStyle/>
           <a:p>
-            <a:pPr indent="0" marL="0">
+            <a:pPr marL="0" indent="0">
               <a:lnSpc>
                 <a:spcPct val="125000"/>
               </a:lnSpc>
@@ -6531,7 +6746,7 @@
             <a:endParaRPr lang="en-US" sz="1100" dirty="0"/>
           </a:p>
           <a:p>
-            <a:pPr indent="0" marL="0">
+            <a:pPr marL="0" indent="0">
               <a:lnSpc>
                 <a:spcPct val="125000"/>
               </a:lnSpc>
@@ -6551,7 +6766,7 @@
             <a:endParaRPr lang="en-US" sz="1100" dirty="0"/>
           </a:p>
           <a:p>
-            <a:pPr indent="0" marL="0">
+            <a:pPr marL="0" indent="0">
               <a:lnSpc>
                 <a:spcPct val="125000"/>
               </a:lnSpc>
@@ -6595,6 +6810,13 @@
             <a:tailEnd type="triangle"/>
           </a:ln>
         </p:spPr>
+        <p:txBody>
+          <a:bodyPr/>
+          <a:lstStyle/>
+          <a:p>
+            <a:endParaRPr lang="en-US"/>
+          </a:p>
+        </p:txBody>
       </p:sp>
       <p:sp>
         <p:nvSpPr>
@@ -6617,6 +6839,13 @@
           </a:solidFill>
           <a:ln/>
         </p:spPr>
+        <p:txBody>
+          <a:bodyPr/>
+          <a:lstStyle/>
+          <a:p>
+            <a:endParaRPr lang="en-US"/>
+          </a:p>
+        </p:txBody>
       </p:sp>
       <p:sp>
         <p:nvSpPr>
@@ -6639,7 +6868,7 @@
           <a:bodyPr wrap="square" rtlCol="0" anchor="ctr"/>
           <a:lstStyle/>
           <a:p>
-            <a:pPr indent="0" marL="0">
+            <a:pPr marL="0" indent="0">
               <a:buNone/>
             </a:pPr>
             <a:r>
@@ -6678,7 +6907,7 @@
           <a:bodyPr wrap="square" rtlCol="0" anchor="ctr"/>
           <a:lstStyle/>
           <a:p>
-            <a:pPr indent="0" marL="0">
+            <a:pPr marL="0" indent="0">
               <a:lnSpc>
                 <a:spcPct val="125000"/>
               </a:lnSpc>
@@ -6698,7 +6927,7 @@
             <a:endParaRPr lang="en-US" sz="1100" dirty="0"/>
           </a:p>
           <a:p>
-            <a:pPr indent="0" marL="0">
+            <a:pPr marL="0" indent="0">
               <a:lnSpc>
                 <a:spcPct val="125000"/>
               </a:lnSpc>
@@ -6718,7 +6947,7 @@
             <a:endParaRPr lang="en-US" sz="1100" dirty="0"/>
           </a:p>
           <a:p>
-            <a:pPr indent="0" marL="0">
+            <a:pPr marL="0" indent="0">
               <a:lnSpc>
                 <a:spcPct val="125000"/>
               </a:lnSpc>
@@ -6760,7 +6989,7 @@
           <a:bodyPr wrap="square" rtlCol="0" anchor="ctr"/>
           <a:lstStyle/>
           <a:p>
-            <a:pPr algn="ctr" indent="0" marL="0">
+            <a:pPr marL="0" indent="0" algn="ctr">
               <a:buNone/>
             </a:pPr>
             <a:r>
@@ -6797,6 +7026,13 @@
           </a:solidFill>
           <a:ln/>
         </p:spPr>
+        <p:txBody>
+          <a:bodyPr/>
+          <a:lstStyle/>
+          <a:p>
+            <a:endParaRPr lang="en-US"/>
+          </a:p>
+        </p:txBody>
       </p:sp>
       <p:sp>
         <p:nvSpPr>
@@ -6819,7 +7055,7 @@
           <a:bodyPr wrap="square" rtlCol="0" anchor="ctr"/>
           <a:lstStyle/>
           <a:p>
-            <a:pPr indent="0" marL="0">
+            <a:pPr marL="0" indent="0">
               <a:buNone/>
             </a:pPr>
             <a:r>
@@ -6858,7 +7094,7 @@
           <a:bodyPr wrap="square" rtlCol="0" anchor="ctr"/>
           <a:lstStyle/>
           <a:p>
-            <a:pPr indent="0" marL="0">
+            <a:pPr marL="0" indent="0">
               <a:buNone/>
             </a:pPr>
             <a:r>
@@ -6897,7 +7133,7 @@
           <a:bodyPr wrap="square" rtlCol="0" anchor="ctr"/>
           <a:lstStyle/>
           <a:p>
-            <a:pPr algn="r" indent="0" marL="0">
+            <a:pPr marL="0" indent="0" algn="r">
               <a:buNone/>
             </a:pPr>
             <a:r>
@@ -6961,7 +7197,7 @@
           <a:bodyPr wrap="square" rtlCol="0" anchor="ctr"/>
           <a:lstStyle/>
           <a:p>
-            <a:pPr indent="0" marL="0">
+            <a:pPr marL="0" indent="0">
               <a:buNone/>
             </a:pPr>
             <a:r>
@@ -6981,14 +7217,14 @@
       </p:sp>
       <p:pic>
         <p:nvPicPr>
-          <p:cNvPr id="3" name="Image 0" descr="/home/claude/pptx_build/images/03_sip_inflow_trend.png">    </p:cNvPr>
+          <p:cNvPr id="3" name="Image 0" descr="/home/claude/pptx_build/images/03_sip_inflow_trend.png"/>
           <p:cNvPicPr>
             <a:picLocks noChangeAspect="1"/>
           </p:cNvPicPr>
           <p:nvPr/>
         </p:nvPicPr>
         <p:blipFill>
-          <a:blip r:embed="rId1"/>
+          <a:blip r:embed="rId3"/>
           <a:stretch>
             <a:fillRect/>
           </a:stretch>
@@ -7005,14 +7241,14 @@
       </p:pic>
       <p:pic>
         <p:nvPicPr>
-          <p:cNvPr id="4" name="Image 1" descr="/home/claude/pptx_build/images/07_folio_growth.png">    </p:cNvPr>
+          <p:cNvPr id="4" name="Image 1" descr="/home/claude/pptx_build/images/07_folio_growth.png"/>
           <p:cNvPicPr>
             <a:picLocks noChangeAspect="1"/>
           </p:cNvPicPr>
           <p:nvPr/>
         </p:nvPicPr>
         <p:blipFill>
-          <a:blip r:embed="rId2"/>
+          <a:blip r:embed="rId4"/>
           <a:stretch>
             <a:fillRect/>
           </a:stretch>
@@ -7046,6 +7282,13 @@
           </a:solidFill>
           <a:ln/>
         </p:spPr>
+        <p:txBody>
+          <a:bodyPr/>
+          <a:lstStyle/>
+          <a:p>
+            <a:endParaRPr lang="en-US"/>
+          </a:p>
+        </p:txBody>
       </p:sp>
       <p:sp>
         <p:nvSpPr>
@@ -7153,7 +7396,7 @@
           <a:bodyPr wrap="square" rtlCol="0" anchor="ctr"/>
           <a:lstStyle/>
           <a:p>
-            <a:pPr indent="0" marL="0">
+            <a:pPr marL="0" indent="0">
               <a:buNone/>
             </a:pPr>
             <a:r>
@@ -7192,7 +7435,7 @@
           <a:bodyPr wrap="square" rtlCol="0" anchor="ctr"/>
           <a:lstStyle/>
           <a:p>
-            <a:pPr algn="r" indent="0" marL="0">
+            <a:pPr marL="0" indent="0" algn="r">
               <a:buNone/>
             </a:pPr>
             <a:r>
@@ -7256,7 +7499,7 @@
           <a:bodyPr wrap="square" rtlCol="0" anchor="ctr"/>
           <a:lstStyle/>
           <a:p>
-            <a:pPr indent="0" marL="0">
+            <a:pPr marL="0" indent="0">
               <a:buNone/>
             </a:pPr>
             <a:r>
@@ -7276,14 +7519,14 @@
       </p:sp>
       <p:pic>
         <p:nvPicPr>
-          <p:cNvPr id="3" name="Image 0" descr="/home/claude/pptx_build/images/02_aum_growth.png">    </p:cNvPr>
+          <p:cNvPr id="3" name="Image 0" descr="/home/claude/pptx_build/images/02_aum_growth.png"/>
           <p:cNvPicPr>
             <a:picLocks noChangeAspect="1"/>
           </p:cNvPicPr>
           <p:nvPr/>
         </p:nvPicPr>
         <p:blipFill>
-          <a:blip r:embed="rId1"/>
+          <a:blip r:embed="rId3"/>
           <a:stretch>
             <a:fillRect/>
           </a:stretch>
@@ -7300,14 +7543,14 @@
       </p:pic>
       <p:pic>
         <p:nvPicPr>
-          <p:cNvPr id="4" name="Image 1" descr="/home/claude/pptx_build/images/05_investor_demographics.png">    </p:cNvPr>
+          <p:cNvPr id="4" name="Image 1" descr="/home/claude/pptx_build/images/05_investor_demographics.png"/>
           <p:cNvPicPr>
             <a:picLocks noChangeAspect="1"/>
           </p:cNvPicPr>
           <p:nvPr/>
         </p:nvPicPr>
         <p:blipFill>
-          <a:blip r:embed="rId2"/>
+          <a:blip r:embed="rId4"/>
           <a:stretch>
             <a:fillRect/>
           </a:stretch>
@@ -7341,6 +7584,13 @@
           </a:solidFill>
           <a:ln/>
         </p:spPr>
+        <p:txBody>
+          <a:bodyPr/>
+          <a:lstStyle/>
+          <a:p>
+            <a:endParaRPr lang="en-US"/>
+          </a:p>
+        </p:txBody>
       </p:sp>
       <p:sp>
         <p:nvSpPr>
@@ -7363,7 +7613,7 @@
           <a:bodyPr wrap="square" rtlCol="0" anchor="ctr"/>
           <a:lstStyle/>
           <a:p>
-            <a:pPr indent="0" marL="0">
+            <a:pPr marL="0" indent="0">
               <a:lnSpc>
                 <a:spcPct val="125000"/>
               </a:lnSpc>
@@ -7403,6 +7653,13 @@
           </a:solidFill>
           <a:ln/>
         </p:spPr>
+        <p:txBody>
+          <a:bodyPr/>
+          <a:lstStyle/>
+          <a:p>
+            <a:endParaRPr lang="en-US"/>
+          </a:p>
+        </p:txBody>
       </p:sp>
       <p:sp>
         <p:nvSpPr>
@@ -7425,7 +7682,7 @@
           <a:bodyPr wrap="square" rtlCol="0" anchor="ctr"/>
           <a:lstStyle/>
           <a:p>
-            <a:pPr indent="0" marL="0">
+            <a:pPr marL="0" indent="0">
               <a:lnSpc>
                 <a:spcPct val="130000"/>
               </a:lnSpc>
@@ -7467,7 +7724,7 @@
           <a:bodyPr wrap="square" rtlCol="0" anchor="ctr"/>
           <a:lstStyle/>
           <a:p>
-            <a:pPr indent="0" marL="0">
+            <a:pPr marL="0" indent="0">
               <a:buNone/>
             </a:pPr>
             <a:r>
@@ -7506,7 +7763,7 @@
           <a:bodyPr wrap="square" rtlCol="0" anchor="ctr"/>
           <a:lstStyle/>
           <a:p>
-            <a:pPr algn="r" indent="0" marL="0">
+            <a:pPr marL="0" indent="0" algn="r">
               <a:buNone/>
             </a:pPr>
             <a:r>
@@ -7570,7 +7827,7 @@
           <a:bodyPr wrap="square" rtlCol="0" anchor="ctr"/>
           <a:lstStyle/>
           <a:p>
-            <a:pPr indent="0" marL="0">
+            <a:pPr marL="0" indent="0">
               <a:buNone/>
             </a:pPr>
             <a:r>
@@ -7604,20 +7861,62 @@
         </p:nvGraphicFramePr>
         <p:xfrm>
           <a:off x="548640" y="1600200"/>
-          <a:ext cx="11064240" cy="2834640"/>
+          <a:ext cx="11064240" cy="2852928"/>
         </p:xfrm>
         <a:graphic>
           <a:graphicData uri="http://schemas.openxmlformats.org/drawingml/2006/table">
             <a:tbl>
               <a:tblPr/>
               <a:tblGrid>
-                <a:gridCol w="3291840"/>
-                <a:gridCol w="1280160"/>
-                <a:gridCol w="1280160"/>
-                <a:gridCol w="1280160"/>
-                <a:gridCol w="1280160"/>
-                <a:gridCol w="1280160"/>
-                <a:gridCol w="1371600"/>
+                <a:gridCol w="3291840">
+                  <a:extLst>
+                    <a:ext uri="{9D8B030D-6E8A-4147-A177-3AD203B41FA5}">
+                      <a16:colId xmlns:a16="http://schemas.microsoft.com/office/drawing/2014/main" val="20000"/>
+                    </a:ext>
+                  </a:extLst>
+                </a:gridCol>
+                <a:gridCol w="1280160">
+                  <a:extLst>
+                    <a:ext uri="{9D8B030D-6E8A-4147-A177-3AD203B41FA5}">
+                      <a16:colId xmlns:a16="http://schemas.microsoft.com/office/drawing/2014/main" val="20001"/>
+                    </a:ext>
+                  </a:extLst>
+                </a:gridCol>
+                <a:gridCol w="1280160">
+                  <a:extLst>
+                    <a:ext uri="{9D8B030D-6E8A-4147-A177-3AD203B41FA5}">
+                      <a16:colId xmlns:a16="http://schemas.microsoft.com/office/drawing/2014/main" val="20002"/>
+                    </a:ext>
+                  </a:extLst>
+                </a:gridCol>
+                <a:gridCol w="1280160">
+                  <a:extLst>
+                    <a:ext uri="{9D8B030D-6E8A-4147-A177-3AD203B41FA5}">
+                      <a16:colId xmlns:a16="http://schemas.microsoft.com/office/drawing/2014/main" val="20003"/>
+                    </a:ext>
+                  </a:extLst>
+                </a:gridCol>
+                <a:gridCol w="1280160">
+                  <a:extLst>
+                    <a:ext uri="{9D8B030D-6E8A-4147-A177-3AD203B41FA5}">
+                      <a16:colId xmlns:a16="http://schemas.microsoft.com/office/drawing/2014/main" val="20004"/>
+                    </a:ext>
+                  </a:extLst>
+                </a:gridCol>
+                <a:gridCol w="1280160">
+                  <a:extLst>
+                    <a:ext uri="{9D8B030D-6E8A-4147-A177-3AD203B41FA5}">
+                      <a16:colId xmlns:a16="http://schemas.microsoft.com/office/drawing/2014/main" val="20005"/>
+                    </a:ext>
+                  </a:extLst>
+                </a:gridCol>
+                <a:gridCol w="1371600">
+                  <a:extLst>
+                    <a:ext uri="{9D8B030D-6E8A-4147-A177-3AD203B41FA5}">
+                      <a16:colId xmlns:a16="http://schemas.microsoft.com/office/drawing/2014/main" val="20006"/>
+                    </a:ext>
+                  </a:extLst>
+                </a:gridCol>
               </a:tblGrid>
               <a:tr h="475488">
                 <a:tc>
@@ -7625,7 +7924,7 @@
                     <a:bodyPr/>
                     <a:lstStyle/>
                     <a:p>
-                      <a:pPr algn="l" indent="0" marL="0">
+                      <a:pPr marL="0" indent="0" algn="l">
                         <a:buNone/>
                       </a:pPr>
                       <a:r>
@@ -7646,7 +7945,7 @@
                       </a:endParaRPr>
                     </a:p>
                   </a:txBody>
-                  <a:tcPr marL="91440" marR="91440" marT="45720" marB="45720" anchor="ctr">
+                  <a:tcPr anchor="ctr">
                     <a:lnL w="6350" cap="flat" cmpd="sng" algn="ctr">
                       <a:solidFill>
                         <a:srgbClr val="E0DCEC"/>
@@ -7693,7 +7992,7 @@
                     <a:bodyPr/>
                     <a:lstStyle/>
                     <a:p>
-                      <a:pPr algn="ctr" indent="0" marL="0">
+                      <a:pPr marL="0" indent="0" algn="ctr">
                         <a:buNone/>
                       </a:pPr>
                       <a:r>
@@ -7714,7 +8013,7 @@
                       </a:endParaRPr>
                     </a:p>
                   </a:txBody>
-                  <a:tcPr marL="91440" marR="91440" marT="45720" marB="45720" anchor="ctr">
+                  <a:tcPr anchor="ctr">
                     <a:lnL w="6350" cap="flat" cmpd="sng" algn="ctr">
                       <a:solidFill>
                         <a:srgbClr val="E0DCEC"/>
@@ -7761,7 +8060,7 @@
                     <a:bodyPr/>
                     <a:lstStyle/>
                     <a:p>
-                      <a:pPr algn="ctr" indent="0" marL="0">
+                      <a:pPr marL="0" indent="0" algn="ctr">
                         <a:buNone/>
                       </a:pPr>
                       <a:r>
@@ -7782,7 +8081,7 @@
                       </a:endParaRPr>
                     </a:p>
                   </a:txBody>
-                  <a:tcPr marL="91440" marR="91440" marT="45720" marB="45720" anchor="ctr">
+                  <a:tcPr anchor="ctr">
                     <a:lnL w="6350" cap="flat" cmpd="sng" algn="ctr">
                       <a:solidFill>
                         <a:srgbClr val="E0DCEC"/>
@@ -7829,7 +8128,7 @@
                     <a:bodyPr/>
                     <a:lstStyle/>
                     <a:p>
-                      <a:pPr algn="ctr" indent="0" marL="0">
+                      <a:pPr marL="0" indent="0" algn="ctr">
                         <a:buNone/>
                       </a:pPr>
                       <a:r>
@@ -7850,7 +8149,7 @@
                       </a:endParaRPr>
                     </a:p>
                   </a:txBody>
-                  <a:tcPr marL="91440" marR="91440" marT="45720" marB="45720" anchor="ctr">
+                  <a:tcPr anchor="ctr">
                     <a:lnL w="6350" cap="flat" cmpd="sng" algn="ctr">
                       <a:solidFill>
                         <a:srgbClr val="E0DCEC"/>
@@ -7897,7 +8196,7 @@
                     <a:bodyPr/>
                     <a:lstStyle/>
                     <a:p>
-                      <a:pPr algn="ctr" indent="0" marL="0">
+                      <a:pPr marL="0" indent="0" algn="ctr">
                         <a:buNone/>
                       </a:pPr>
                       <a:r>
@@ -7918,7 +8217,7 @@
                       </a:endParaRPr>
                     </a:p>
                   </a:txBody>
-                  <a:tcPr marL="91440" marR="91440" marT="45720" marB="45720" anchor="ctr">
+                  <a:tcPr anchor="ctr">
                     <a:lnL w="6350" cap="flat" cmpd="sng" algn="ctr">
                       <a:solidFill>
                         <a:srgbClr val="E0DCEC"/>
@@ -7965,7 +8264,7 @@
                     <a:bodyPr/>
                     <a:lstStyle/>
                     <a:p>
-                      <a:pPr algn="ctr" indent="0" marL="0">
+                      <a:pPr marL="0" indent="0" algn="ctr">
                         <a:buNone/>
                       </a:pPr>
                       <a:r>
@@ -7986,7 +8285,7 @@
                       </a:endParaRPr>
                     </a:p>
                   </a:txBody>
-                  <a:tcPr marL="91440" marR="91440" marT="45720" marB="45720" anchor="ctr">
+                  <a:tcPr anchor="ctr">
                     <a:lnL w="6350" cap="flat" cmpd="sng" algn="ctr">
                       <a:solidFill>
                         <a:srgbClr val="E0DCEC"/>
@@ -8033,7 +8332,7 @@
                     <a:bodyPr/>
                     <a:lstStyle/>
                     <a:p>
-                      <a:pPr algn="ctr" indent="0" marL="0">
+                      <a:pPr marL="0" indent="0" algn="ctr">
                         <a:buNone/>
                       </a:pPr>
                       <a:r>
@@ -8054,7 +8353,7 @@
                       </a:endParaRPr>
                     </a:p>
                   </a:txBody>
-                  <a:tcPr marL="91440" marR="91440" marT="45720" marB="45720" anchor="ctr">
+                  <a:tcPr anchor="ctr">
                     <a:lnL w="6350" cap="flat" cmpd="sng" algn="ctr">
                       <a:solidFill>
                         <a:srgbClr val="E0DCEC"/>
@@ -8096,6 +8395,11 @@
                     </a:solidFill>
                   </a:tcPr>
                 </a:tc>
+                <a:extLst>
+                  <a:ext uri="{0D108BD9-81ED-4DB2-BD59-A6C34878D82A}">
+                    <a16:rowId xmlns:a16="http://schemas.microsoft.com/office/drawing/2014/main" val="10000"/>
+                  </a:ext>
+                </a:extLst>
               </a:tr>
               <a:tr h="475488">
                 <a:tc>
@@ -8103,7 +8407,7 @@
                     <a:bodyPr/>
                     <a:lstStyle/>
                     <a:p>
-                      <a:pPr algn="l" indent="0" marL="0">
+                      <a:pPr marL="0" indent="0" algn="l">
                         <a:buNone/>
                       </a:pPr>
                       <a:r>
@@ -8124,7 +8428,7 @@
                       </a:endParaRPr>
                     </a:p>
                   </a:txBody>
-                  <a:tcPr marL="91440" marR="91440" marT="45720" marB="45720" anchor="ctr">
+                  <a:tcPr anchor="ctr">
                     <a:lnL w="6350" cap="flat" cmpd="sng" algn="ctr">
                       <a:solidFill>
                         <a:srgbClr val="E0DCEC"/>
@@ -8171,7 +8475,7 @@
                     <a:bodyPr/>
                     <a:lstStyle/>
                     <a:p>
-                      <a:pPr algn="ctr" indent="0" marL="0">
+                      <a:pPr marL="0" indent="0" algn="ctr">
                         <a:buNone/>
                       </a:pPr>
                       <a:r>
@@ -8192,7 +8496,7 @@
                       </a:endParaRPr>
                     </a:p>
                   </a:txBody>
-                  <a:tcPr marL="91440" marR="91440" marT="45720" marB="45720" anchor="ctr">
+                  <a:tcPr anchor="ctr">
                     <a:lnL w="6350" cap="flat" cmpd="sng" algn="ctr">
                       <a:solidFill>
                         <a:srgbClr val="E0DCEC"/>
@@ -8239,7 +8543,7 @@
                     <a:bodyPr/>
                     <a:lstStyle/>
                     <a:p>
-                      <a:pPr algn="ctr" indent="0" marL="0">
+                      <a:pPr marL="0" indent="0" algn="ctr">
                         <a:buNone/>
                       </a:pPr>
                       <a:r>
@@ -8260,7 +8564,7 @@
                       </a:endParaRPr>
                     </a:p>
                   </a:txBody>
-                  <a:tcPr marL="91440" marR="91440" marT="45720" marB="45720" anchor="ctr">
+                  <a:tcPr anchor="ctr">
                     <a:lnL w="6350" cap="flat" cmpd="sng" algn="ctr">
                       <a:solidFill>
                         <a:srgbClr val="E0DCEC"/>
@@ -8307,7 +8611,7 @@
                     <a:bodyPr/>
                     <a:lstStyle/>
                     <a:p>
-                      <a:pPr algn="ctr" indent="0" marL="0">
+                      <a:pPr marL="0" indent="0" algn="ctr">
                         <a:buNone/>
                       </a:pPr>
                       <a:r>
@@ -8328,7 +8632,7 @@
                       </a:endParaRPr>
                     </a:p>
                   </a:txBody>
-                  <a:tcPr marL="91440" marR="91440" marT="45720" marB="45720" anchor="ctr">
+                  <a:tcPr anchor="ctr">
                     <a:lnL w="6350" cap="flat" cmpd="sng" algn="ctr">
                       <a:solidFill>
                         <a:srgbClr val="E0DCEC"/>
@@ -8375,7 +8679,7 @@
                     <a:bodyPr/>
                     <a:lstStyle/>
                     <a:p>
-                      <a:pPr algn="ctr" indent="0" marL="0">
+                      <a:pPr marL="0" indent="0" algn="ctr">
                         <a:buNone/>
                       </a:pPr>
                       <a:r>
@@ -8396,7 +8700,7 @@
                       </a:endParaRPr>
                     </a:p>
                   </a:txBody>
-                  <a:tcPr marL="91440" marR="91440" marT="45720" marB="45720" anchor="ctr">
+                  <a:tcPr anchor="ctr">
                     <a:lnL w="6350" cap="flat" cmpd="sng" algn="ctr">
                       <a:solidFill>
                         <a:srgbClr val="E0DCEC"/>
@@ -8443,7 +8747,7 @@
                     <a:bodyPr/>
                     <a:lstStyle/>
                     <a:p>
-                      <a:pPr algn="ctr" indent="0" marL="0">
+                      <a:pPr marL="0" indent="0" algn="ctr">
                         <a:buNone/>
                       </a:pPr>
                       <a:r>
@@ -8464,7 +8768,7 @@
                       </a:endParaRPr>
                     </a:p>
                   </a:txBody>
-                  <a:tcPr marL="91440" marR="91440" marT="45720" marB="45720" anchor="ctr">
+                  <a:tcPr anchor="ctr">
                     <a:lnL w="6350" cap="flat" cmpd="sng" algn="ctr">
                       <a:solidFill>
                         <a:srgbClr val="E0DCEC"/>
@@ -8511,7 +8815,7 @@
                     <a:bodyPr/>
                     <a:lstStyle/>
                     <a:p>
-                      <a:pPr algn="ctr" indent="0" marL="0">
+                      <a:pPr marL="0" indent="0" algn="ctr">
                         <a:buNone/>
                       </a:pPr>
                       <a:r>
@@ -8532,7 +8836,7 @@
                       </a:endParaRPr>
                     </a:p>
                   </a:txBody>
-                  <a:tcPr marL="91440" marR="91440" marT="45720" marB="45720" anchor="ctr">
+                  <a:tcPr anchor="ctr">
                     <a:lnL w="6350" cap="flat" cmpd="sng" algn="ctr">
                       <a:solidFill>
                         <a:srgbClr val="E0DCEC"/>
@@ -8574,6 +8878,11 @@
                     </a:solidFill>
                   </a:tcPr>
                 </a:tc>
+                <a:extLst>
+                  <a:ext uri="{0D108BD9-81ED-4DB2-BD59-A6C34878D82A}">
+                    <a16:rowId xmlns:a16="http://schemas.microsoft.com/office/drawing/2014/main" val="10001"/>
+                  </a:ext>
+                </a:extLst>
               </a:tr>
               <a:tr h="475488">
                 <a:tc>
@@ -8581,7 +8890,7 @@
                     <a:bodyPr/>
                     <a:lstStyle/>
                     <a:p>
-                      <a:pPr algn="l" indent="0" marL="0">
+                      <a:pPr marL="0" indent="0" algn="l">
                         <a:buNone/>
                       </a:pPr>
                       <a:r>
@@ -8602,7 +8911,7 @@
                       </a:endParaRPr>
                     </a:p>
                   </a:txBody>
-                  <a:tcPr marL="91440" marR="91440" marT="45720" marB="45720" anchor="ctr">
+                  <a:tcPr anchor="ctr">
                     <a:lnL w="6350" cap="flat" cmpd="sng" algn="ctr">
                       <a:solidFill>
                         <a:srgbClr val="E0DCEC"/>
@@ -8649,7 +8958,7 @@
                     <a:bodyPr/>
                     <a:lstStyle/>
                     <a:p>
-                      <a:pPr algn="ctr" indent="0" marL="0">
+                      <a:pPr marL="0" indent="0" algn="ctr">
                         <a:buNone/>
                       </a:pPr>
                       <a:r>
@@ -8670,7 +8979,7 @@
                       </a:endParaRPr>
                     </a:p>
                   </a:txBody>
-                  <a:tcPr marL="91440" marR="91440" marT="45720" marB="45720" anchor="ctr">
+                  <a:tcPr anchor="ctr">
                     <a:lnL w="6350" cap="flat" cmpd="sng" algn="ctr">
                       <a:solidFill>
                         <a:srgbClr val="E0DCEC"/>
@@ -8717,7 +9026,7 @@
                     <a:bodyPr/>
                     <a:lstStyle/>
                     <a:p>
-                      <a:pPr algn="ctr" indent="0" marL="0">
+                      <a:pPr marL="0" indent="0" algn="ctr">
                         <a:buNone/>
                       </a:pPr>
                       <a:r>
@@ -8738,7 +9047,7 @@
                       </a:endParaRPr>
                     </a:p>
                   </a:txBody>
-                  <a:tcPr marL="91440" marR="91440" marT="45720" marB="45720" anchor="ctr">
+                  <a:tcPr anchor="ctr">
                     <a:lnL w="6350" cap="flat" cmpd="sng" algn="ctr">
                       <a:solidFill>
                         <a:srgbClr val="E0DCEC"/>
@@ -8785,7 +9094,7 @@
                     <a:bodyPr/>
                     <a:lstStyle/>
                     <a:p>
-                      <a:pPr algn="ctr" indent="0" marL="0">
+                      <a:pPr marL="0" indent="0" algn="ctr">
                         <a:buNone/>
                       </a:pPr>
                       <a:r>
@@ -8806,7 +9115,7 @@
                       </a:endParaRPr>
                     </a:p>
                   </a:txBody>
-                  <a:tcPr marL="91440" marR="91440" marT="45720" marB="45720" anchor="ctr">
+                  <a:tcPr anchor="ctr">
                     <a:lnL w="6350" cap="flat" cmpd="sng" algn="ctr">
                       <a:solidFill>
                         <a:srgbClr val="E0DCEC"/>
@@ -8853,7 +9162,7 @@
                     <a:bodyPr/>
                     <a:lstStyle/>
                     <a:p>
-                      <a:pPr algn="ctr" indent="0" marL="0">
+                      <a:pPr marL="0" indent="0" algn="ctr">
                         <a:buNone/>
                       </a:pPr>
                       <a:r>
@@ -8874,7 +9183,7 @@
                       </a:endParaRPr>
                     </a:p>
                   </a:txBody>
-                  <a:tcPr marL="91440" marR="91440" marT="45720" marB="45720" anchor="ctr">
+                  <a:tcPr anchor="ctr">
                     <a:lnL w="6350" cap="flat" cmpd="sng" algn="ctr">
                       <a:solidFill>
                         <a:srgbClr val="E0DCEC"/>
@@ -8921,7 +9230,7 @@
                     <a:bodyPr/>
                     <a:lstStyle/>
                     <a:p>
-                      <a:pPr algn="ctr" indent="0" marL="0">
+                      <a:pPr marL="0" indent="0" algn="ctr">
                         <a:buNone/>
                       </a:pPr>
                       <a:r>
@@ -8942,7 +9251,7 @@
                       </a:endParaRPr>
                     </a:p>
                   </a:txBody>
-                  <a:tcPr marL="91440" marR="91440" marT="45720" marB="45720" anchor="ctr">
+                  <a:tcPr anchor="ctr">
                     <a:lnL w="6350" cap="flat" cmpd="sng" algn="ctr">
                       <a:solidFill>
                         <a:srgbClr val="E0DCEC"/>
@@ -8989,7 +9298,7 @@
                     <a:bodyPr/>
                     <a:lstStyle/>
                     <a:p>
-                      <a:pPr algn="ctr" indent="0" marL="0">
+                      <a:pPr marL="0" indent="0" algn="ctr">
                         <a:buNone/>
                       </a:pPr>
                       <a:r>
@@ -9010,7 +9319,7 @@
                       </a:endParaRPr>
                     </a:p>
                   </a:txBody>
-                  <a:tcPr marL="91440" marR="91440" marT="45720" marB="45720" anchor="ctr">
+                  <a:tcPr anchor="ctr">
                     <a:lnL w="6350" cap="flat" cmpd="sng" algn="ctr">
                       <a:solidFill>
                         <a:srgbClr val="E0DCEC"/>
@@ -9052,6 +9361,11 @@
                     </a:solidFill>
                   </a:tcPr>
                 </a:tc>
+                <a:extLst>
+                  <a:ext uri="{0D108BD9-81ED-4DB2-BD59-A6C34878D82A}">
+                    <a16:rowId xmlns:a16="http://schemas.microsoft.com/office/drawing/2014/main" val="10002"/>
+                  </a:ext>
+                </a:extLst>
               </a:tr>
               <a:tr h="475488">
                 <a:tc>
@@ -9059,7 +9373,7 @@
                     <a:bodyPr/>
                     <a:lstStyle/>
                     <a:p>
-                      <a:pPr algn="l" indent="0" marL="0">
+                      <a:pPr marL="0" indent="0" algn="l">
                         <a:buNone/>
                       </a:pPr>
                       <a:r>
@@ -9080,7 +9394,7 @@
                       </a:endParaRPr>
                     </a:p>
                   </a:txBody>
-                  <a:tcPr marL="91440" marR="91440" marT="45720" marB="45720" anchor="ctr">
+                  <a:tcPr anchor="ctr">
                     <a:lnL w="6350" cap="flat" cmpd="sng" algn="ctr">
                       <a:solidFill>
                         <a:srgbClr val="E0DCEC"/>
@@ -9127,7 +9441,7 @@
                     <a:bodyPr/>
                     <a:lstStyle/>
                     <a:p>
-                      <a:pPr algn="ctr" indent="0" marL="0">
+                      <a:pPr marL="0" indent="0" algn="ctr">
                         <a:buNone/>
                       </a:pPr>
                       <a:r>
@@ -9148,7 +9462,7 @@
                       </a:endParaRPr>
                     </a:p>
                   </a:txBody>
-                  <a:tcPr marL="91440" marR="91440" marT="45720" marB="45720" anchor="ctr">
+                  <a:tcPr anchor="ctr">
                     <a:lnL w="6350" cap="flat" cmpd="sng" algn="ctr">
                       <a:solidFill>
                         <a:srgbClr val="E0DCEC"/>
@@ -9195,7 +9509,7 @@
                     <a:bodyPr/>
                     <a:lstStyle/>
                     <a:p>
-                      <a:pPr algn="ctr" indent="0" marL="0">
+                      <a:pPr marL="0" indent="0" algn="ctr">
                         <a:buNone/>
                       </a:pPr>
                       <a:r>
@@ -9216,7 +9530,7 @@
                       </a:endParaRPr>
                     </a:p>
                   </a:txBody>
-                  <a:tcPr marL="91440" marR="91440" marT="45720" marB="45720" anchor="ctr">
+                  <a:tcPr anchor="ctr">
                     <a:lnL w="6350" cap="flat" cmpd="sng" algn="ctr">
                       <a:solidFill>
                         <a:srgbClr val="E0DCEC"/>
@@ -9263,7 +9577,7 @@
                     <a:bodyPr/>
                     <a:lstStyle/>
                     <a:p>
-                      <a:pPr algn="ctr" indent="0" marL="0">
+                      <a:pPr marL="0" indent="0" algn="ctr">
                         <a:buNone/>
                       </a:pPr>
                       <a:r>
@@ -9284,7 +9598,7 @@
                       </a:endParaRPr>
                     </a:p>
                   </a:txBody>
-                  <a:tcPr marL="91440" marR="91440" marT="45720" marB="45720" anchor="ctr">
+                  <a:tcPr anchor="ctr">
                     <a:lnL w="6350" cap="flat" cmpd="sng" algn="ctr">
                       <a:solidFill>
                         <a:srgbClr val="E0DCEC"/>
@@ -9331,7 +9645,7 @@
                     <a:bodyPr/>
                     <a:lstStyle/>
                     <a:p>
-                      <a:pPr algn="ctr" indent="0" marL="0">
+                      <a:pPr marL="0" indent="0" algn="ctr">
                         <a:buNone/>
                       </a:pPr>
                       <a:r>
@@ -9352,7 +9666,7 @@
                       </a:endParaRPr>
                     </a:p>
                   </a:txBody>
-                  <a:tcPr marL="91440" marR="91440" marT="45720" marB="45720" anchor="ctr">
+                  <a:tcPr anchor="ctr">
                     <a:lnL w="6350" cap="flat" cmpd="sng" algn="ctr">
                       <a:solidFill>
                         <a:srgbClr val="E0DCEC"/>
@@ -9399,7 +9713,7 @@
                     <a:bodyPr/>
                     <a:lstStyle/>
                     <a:p>
-                      <a:pPr algn="ctr" indent="0" marL="0">
+                      <a:pPr marL="0" indent="0" algn="ctr">
                         <a:buNone/>
                       </a:pPr>
                       <a:r>
@@ -9420,7 +9734,7 @@
                       </a:endParaRPr>
                     </a:p>
                   </a:txBody>
-                  <a:tcPr marL="91440" marR="91440" marT="45720" marB="45720" anchor="ctr">
+                  <a:tcPr anchor="ctr">
                     <a:lnL w="6350" cap="flat" cmpd="sng" algn="ctr">
                       <a:solidFill>
                         <a:srgbClr val="E0DCEC"/>
@@ -9467,7 +9781,7 @@
                     <a:bodyPr/>
                     <a:lstStyle/>
                     <a:p>
-                      <a:pPr algn="ctr" indent="0" marL="0">
+                      <a:pPr marL="0" indent="0" algn="ctr">
                         <a:buNone/>
                       </a:pPr>
                       <a:r>
@@ -9488,7 +9802,7 @@
                       </a:endParaRPr>
                     </a:p>
                   </a:txBody>
-                  <a:tcPr marL="91440" marR="91440" marT="45720" marB="45720" anchor="ctr">
+                  <a:tcPr anchor="ctr">
                     <a:lnL w="6350" cap="flat" cmpd="sng" algn="ctr">
                       <a:solidFill>
                         <a:srgbClr val="E0DCEC"/>
@@ -9530,6 +9844,11 @@
                     </a:solidFill>
                   </a:tcPr>
                 </a:tc>
+                <a:extLst>
+                  <a:ext uri="{0D108BD9-81ED-4DB2-BD59-A6C34878D82A}">
+                    <a16:rowId xmlns:a16="http://schemas.microsoft.com/office/drawing/2014/main" val="10003"/>
+                  </a:ext>
+                </a:extLst>
               </a:tr>
               <a:tr h="475488">
                 <a:tc>
@@ -9537,7 +9856,7 @@
                     <a:bodyPr/>
                     <a:lstStyle/>
                     <a:p>
-                      <a:pPr algn="l" indent="0" marL="0">
+                      <a:pPr marL="0" indent="0" algn="l">
                         <a:buNone/>
                       </a:pPr>
                       <a:r>
@@ -9558,7 +9877,7 @@
                       </a:endParaRPr>
                     </a:p>
                   </a:txBody>
-                  <a:tcPr marL="91440" marR="91440" marT="45720" marB="45720" anchor="ctr">
+                  <a:tcPr anchor="ctr">
                     <a:lnL w="6350" cap="flat" cmpd="sng" algn="ctr">
                       <a:solidFill>
                         <a:srgbClr val="E0DCEC"/>
@@ -9605,7 +9924,7 @@
                     <a:bodyPr/>
                     <a:lstStyle/>
                     <a:p>
-                      <a:pPr algn="ctr" indent="0" marL="0">
+                      <a:pPr marL="0" indent="0" algn="ctr">
                         <a:buNone/>
                       </a:pPr>
                       <a:r>
@@ -9626,7 +9945,7 @@
                       </a:endParaRPr>
                     </a:p>
                   </a:txBody>
-                  <a:tcPr marL="91440" marR="91440" marT="45720" marB="45720" anchor="ctr">
+                  <a:tcPr anchor="ctr">
                     <a:lnL w="6350" cap="flat" cmpd="sng" algn="ctr">
                       <a:solidFill>
                         <a:srgbClr val="E0DCEC"/>
@@ -9673,7 +9992,7 @@
                     <a:bodyPr/>
                     <a:lstStyle/>
                     <a:p>
-                      <a:pPr algn="ctr" indent="0" marL="0">
+                      <a:pPr marL="0" indent="0" algn="ctr">
                         <a:buNone/>
                       </a:pPr>
                       <a:r>
@@ -9694,7 +10013,7 @@
                       </a:endParaRPr>
                     </a:p>
                   </a:txBody>
-                  <a:tcPr marL="91440" marR="91440" marT="45720" marB="45720" anchor="ctr">
+                  <a:tcPr anchor="ctr">
                     <a:lnL w="6350" cap="flat" cmpd="sng" algn="ctr">
                       <a:solidFill>
                         <a:srgbClr val="E0DCEC"/>
@@ -9741,7 +10060,7 @@
                     <a:bodyPr/>
                     <a:lstStyle/>
                     <a:p>
-                      <a:pPr algn="ctr" indent="0" marL="0">
+                      <a:pPr marL="0" indent="0" algn="ctr">
                         <a:buNone/>
                       </a:pPr>
                       <a:r>
@@ -9762,7 +10081,7 @@
                       </a:endParaRPr>
                     </a:p>
                   </a:txBody>
-                  <a:tcPr marL="91440" marR="91440" marT="45720" marB="45720" anchor="ctr">
+                  <a:tcPr anchor="ctr">
                     <a:lnL w="6350" cap="flat" cmpd="sng" algn="ctr">
                       <a:solidFill>
                         <a:srgbClr val="E0DCEC"/>
@@ -9809,7 +10128,7 @@
                     <a:bodyPr/>
                     <a:lstStyle/>
                     <a:p>
-                      <a:pPr algn="ctr" indent="0" marL="0">
+                      <a:pPr marL="0" indent="0" algn="ctr">
                         <a:buNone/>
                       </a:pPr>
                       <a:r>
@@ -9830,7 +10149,7 @@
                       </a:endParaRPr>
                     </a:p>
                   </a:txBody>
-                  <a:tcPr marL="91440" marR="91440" marT="45720" marB="45720" anchor="ctr">
+                  <a:tcPr anchor="ctr">
                     <a:lnL w="6350" cap="flat" cmpd="sng" algn="ctr">
                       <a:solidFill>
                         <a:srgbClr val="E0DCEC"/>
@@ -9877,7 +10196,7 @@
                     <a:bodyPr/>
                     <a:lstStyle/>
                     <a:p>
-                      <a:pPr algn="ctr" indent="0" marL="0">
+                      <a:pPr marL="0" indent="0" algn="ctr">
                         <a:buNone/>
                       </a:pPr>
                       <a:r>
@@ -9898,7 +10217,7 @@
                       </a:endParaRPr>
                     </a:p>
                   </a:txBody>
-                  <a:tcPr marL="91440" marR="91440" marT="45720" marB="45720" anchor="ctr">
+                  <a:tcPr anchor="ctr">
                     <a:lnL w="6350" cap="flat" cmpd="sng" algn="ctr">
                       <a:solidFill>
                         <a:srgbClr val="E0DCEC"/>
@@ -9945,7 +10264,7 @@
                     <a:bodyPr/>
                     <a:lstStyle/>
                     <a:p>
-                      <a:pPr algn="ctr" indent="0" marL="0">
+                      <a:pPr marL="0" indent="0" algn="ctr">
                         <a:buNone/>
                       </a:pPr>
                       <a:r>
@@ -9966,7 +10285,7 @@
                       </a:endParaRPr>
                     </a:p>
                   </a:txBody>
-                  <a:tcPr marL="91440" marR="91440" marT="45720" marB="45720" anchor="ctr">
+                  <a:tcPr anchor="ctr">
                     <a:lnL w="6350" cap="flat" cmpd="sng" algn="ctr">
                       <a:solidFill>
                         <a:srgbClr val="E0DCEC"/>
@@ -10008,6 +10327,11 @@
                     </a:solidFill>
                   </a:tcPr>
                 </a:tc>
+                <a:extLst>
+                  <a:ext uri="{0D108BD9-81ED-4DB2-BD59-A6C34878D82A}">
+                    <a16:rowId xmlns:a16="http://schemas.microsoft.com/office/drawing/2014/main" val="10004"/>
+                  </a:ext>
+                </a:extLst>
               </a:tr>
               <a:tr h="475488">
                 <a:tc>
@@ -10015,7 +10339,7 @@
                     <a:bodyPr/>
                     <a:lstStyle/>
                     <a:p>
-                      <a:pPr algn="l" indent="0" marL="0">
+                      <a:pPr marL="0" indent="0" algn="l">
                         <a:buNone/>
                       </a:pPr>
                       <a:r>
@@ -10036,7 +10360,7 @@
                       </a:endParaRPr>
                     </a:p>
                   </a:txBody>
-                  <a:tcPr marL="91440" marR="91440" marT="45720" marB="45720" anchor="ctr">
+                  <a:tcPr anchor="ctr">
                     <a:lnL w="6350" cap="flat" cmpd="sng" algn="ctr">
                       <a:solidFill>
                         <a:srgbClr val="E0DCEC"/>
@@ -10083,7 +10407,7 @@
                     <a:bodyPr/>
                     <a:lstStyle/>
                     <a:p>
-                      <a:pPr algn="ctr" indent="0" marL="0">
+                      <a:pPr marL="0" indent="0" algn="ctr">
                         <a:buNone/>
                       </a:pPr>
                       <a:r>
@@ -10104,7 +10428,7 @@
                       </a:endParaRPr>
                     </a:p>
                   </a:txBody>
-                  <a:tcPr marL="91440" marR="91440" marT="45720" marB="45720" anchor="ctr">
+                  <a:tcPr anchor="ctr">
                     <a:lnL w="6350" cap="flat" cmpd="sng" algn="ctr">
                       <a:solidFill>
                         <a:srgbClr val="E0DCEC"/>
@@ -10151,7 +10475,7 @@
                     <a:bodyPr/>
                     <a:lstStyle/>
                     <a:p>
-                      <a:pPr algn="ctr" indent="0" marL="0">
+                      <a:pPr marL="0" indent="0" algn="ctr">
                         <a:buNone/>
                       </a:pPr>
                       <a:r>
@@ -10172,7 +10496,7 @@
                       </a:endParaRPr>
                     </a:p>
                   </a:txBody>
-                  <a:tcPr marL="91440" marR="91440" marT="45720" marB="45720" anchor="ctr">
+                  <a:tcPr anchor="ctr">
                     <a:lnL w="6350" cap="flat" cmpd="sng" algn="ctr">
                       <a:solidFill>
                         <a:srgbClr val="E0DCEC"/>
@@ -10219,7 +10543,7 @@
                     <a:bodyPr/>
                     <a:lstStyle/>
                     <a:p>
-                      <a:pPr algn="ctr" indent="0" marL="0">
+                      <a:pPr marL="0" indent="0" algn="ctr">
                         <a:buNone/>
                       </a:pPr>
                       <a:r>
@@ -10240,7 +10564,7 @@
                       </a:endParaRPr>
                     </a:p>
                   </a:txBody>
-                  <a:tcPr marL="91440" marR="91440" marT="45720" marB="45720" anchor="ctr">
+                  <a:tcPr anchor="ctr">
                     <a:lnL w="6350" cap="flat" cmpd="sng" algn="ctr">
                       <a:solidFill>
                         <a:srgbClr val="E0DCEC"/>
@@ -10287,7 +10611,7 @@
                     <a:bodyPr/>
                     <a:lstStyle/>
                     <a:p>
-                      <a:pPr algn="ctr" indent="0" marL="0">
+                      <a:pPr marL="0" indent="0" algn="ctr">
                         <a:buNone/>
                       </a:pPr>
                       <a:r>
@@ -10308,7 +10632,7 @@
                       </a:endParaRPr>
                     </a:p>
                   </a:txBody>
-                  <a:tcPr marL="91440" marR="91440" marT="45720" marB="45720" anchor="ctr">
+                  <a:tcPr anchor="ctr">
                     <a:lnL w="6350" cap="flat" cmpd="sng" algn="ctr">
                       <a:solidFill>
                         <a:srgbClr val="E0DCEC"/>
@@ -10355,7 +10679,7 @@
                     <a:bodyPr/>
                     <a:lstStyle/>
                     <a:p>
-                      <a:pPr algn="ctr" indent="0" marL="0">
+                      <a:pPr marL="0" indent="0" algn="ctr">
                         <a:buNone/>
                       </a:pPr>
                       <a:r>
@@ -10376,7 +10700,7 @@
                       </a:endParaRPr>
                     </a:p>
                   </a:txBody>
-                  <a:tcPr marL="91440" marR="91440" marT="45720" marB="45720" anchor="ctr">
+                  <a:tcPr anchor="ctr">
                     <a:lnL w="6350" cap="flat" cmpd="sng" algn="ctr">
                       <a:solidFill>
                         <a:srgbClr val="E0DCEC"/>
@@ -10423,7 +10747,7 @@
                     <a:bodyPr/>
                     <a:lstStyle/>
                     <a:p>
-                      <a:pPr algn="ctr" indent="0" marL="0">
+                      <a:pPr marL="0" indent="0" algn="ctr">
                         <a:buNone/>
                       </a:pPr>
                       <a:r>
@@ -10444,7 +10768,7 @@
                       </a:endParaRPr>
                     </a:p>
                   </a:txBody>
-                  <a:tcPr marL="91440" marR="91440" marT="45720" marB="45720" anchor="ctr">
+                  <a:tcPr anchor="ctr">
                     <a:lnL w="6350" cap="flat" cmpd="sng" algn="ctr">
                       <a:solidFill>
                         <a:srgbClr val="E0DCEC"/>
@@ -10486,6 +10810,11 @@
                     </a:solidFill>
                   </a:tcPr>
                 </a:tc>
+                <a:extLst>
+                  <a:ext uri="{0D108BD9-81ED-4DB2-BD59-A6C34878D82A}">
+                    <a16:rowId xmlns:a16="http://schemas.microsoft.com/office/drawing/2014/main" val="10005"/>
+                  </a:ext>
+                </a:extLst>
               </a:tr>
             </a:tbl>
           </a:graphicData>
@@ -10510,6 +10839,13 @@
           </a:solidFill>
           <a:ln/>
         </p:spPr>
+        <p:txBody>
+          <a:bodyPr/>
+          <a:lstStyle/>
+          <a:p>
+            <a:endParaRPr lang="en-US"/>
+          </a:p>
+        </p:txBody>
       </p:sp>
       <p:sp>
         <p:nvSpPr>
@@ -10532,7 +10868,7 @@
           <a:bodyPr wrap="square" rtlCol="0" anchor="ctr"/>
           <a:lstStyle/>
           <a:p>
-            <a:pPr indent="0" marL="0">
+            <a:pPr marL="0" indent="0">
               <a:lnSpc>
                 <a:spcPct val="130000"/>
               </a:lnSpc>
@@ -10574,7 +10910,7 @@
           <a:bodyPr wrap="square" rtlCol="0" anchor="ctr"/>
           <a:lstStyle/>
           <a:p>
-            <a:pPr indent="0" marL="0">
+            <a:pPr marL="0" indent="0">
               <a:buNone/>
             </a:pPr>
             <a:r>
@@ -10613,7 +10949,7 @@
           <a:bodyPr wrap="square" rtlCol="0" anchor="ctr"/>
           <a:lstStyle/>
           <a:p>
-            <a:pPr algn="r" indent="0" marL="0">
+            <a:pPr marL="0" indent="0" algn="r">
               <a:buNone/>
             </a:pPr>
             <a:r>
@@ -10664,7 +11000,7 @@
         </p:nvSpPr>
         <p:spPr>
           <a:xfrm>
-            <a:off x="548640" y="365760"/>
+            <a:off x="640080" y="434340"/>
             <a:ext cx="11064240" cy="640080"/>
           </a:xfrm>
           <a:prstGeom prst="rect">
@@ -10677,7 +11013,7 @@
           <a:bodyPr wrap="square" rtlCol="0" anchor="ctr"/>
           <a:lstStyle/>
           <a:p>
-            <a:pPr indent="0" marL="0">
+            <a:pPr marL="0" indent="0">
               <a:buNone/>
             </a:pPr>
             <a:r>
@@ -10697,14 +11033,14 @@
       </p:sp>
       <p:pic>
         <p:nvPicPr>
-          <p:cNvPr id="3" name="Image 0" descr="/home/claude/pptx_build/images/benchmark_comparison.png">    </p:cNvPr>
+          <p:cNvPr id="3" name="Image 0" descr="/home/claude/pptx_build/images/benchmark_comparison.png"/>
           <p:cNvPicPr>
             <a:picLocks noChangeAspect="1"/>
           </p:cNvPicPr>
           <p:nvPr/>
         </p:nvPicPr>
         <p:blipFill>
-          <a:blip r:embed="rId1"/>
+          <a:blip r:embed="rId3"/>
           <a:stretch>
             <a:fillRect/>
           </a:stretch>
@@ -10740,7 +11076,7 @@
           <a:bodyPr wrap="square" rtlCol="0" anchor="ctr"/>
           <a:lstStyle/>
           <a:p>
-            <a:pPr indent="0" marL="0">
+            <a:pPr marL="0" indent="0">
               <a:buNone/>
             </a:pPr>
             <a:r>
@@ -10779,7 +11115,7 @@
           <a:bodyPr wrap="square" rtlCol="0" anchor="ctr"/>
           <a:lstStyle/>
           <a:p>
-            <a:pPr algn="r" indent="0" marL="0">
+            <a:pPr marL="0" indent="0" algn="r">
               <a:buNone/>
             </a:pPr>
             <a:r>
@@ -10807,7 +11143,7 @@
 
 <file path=ppt/slides/slide9.xml><?xml version="1.0" encoding="utf-8"?>
 <p:sld xmlns:a="http://schemas.openxmlformats.org/drawingml/2006/main" xmlns:r="http://schemas.openxmlformats.org/officeDocument/2006/relationships" xmlns:p="http://schemas.openxmlformats.org/presentationml/2006/main">
-  <p:cSld name="Slide 9">
+  <p:cSld>
     <p:spTree>
       <p:nvGrpSpPr>
         <p:cNvPr id="1" name=""/>
@@ -10824,28 +11160,32 @@
       </p:grpSpPr>
       <p:sp>
         <p:nvSpPr>
-          <p:cNvPr id="2" name="Text 0"/>
-          <p:cNvSpPr/>
-          <p:nvPr/>
-        </p:nvSpPr>
-        <p:spPr>
-          <a:xfrm>
-            <a:off x="548640" y="365760"/>
-            <a:ext cx="11064240" cy="640080"/>
+          <p:cNvPr id="2" name="TextBox 1">
+            <a:extLst>
+              <a:ext uri="{FF2B5EF4-FFF2-40B4-BE49-F238E27FC236}">
+                <a16:creationId xmlns:a16="http://schemas.microsoft.com/office/drawing/2014/main" id="{77BD2BB1-C3CF-040F-7B8D-17744E891937}"/>
+              </a:ext>
+            </a:extLst>
+          </p:cNvPr>
+          <p:cNvSpPr txBox="1"/>
+          <p:nvPr/>
+        </p:nvSpPr>
+        <p:spPr>
+          <a:xfrm>
+            <a:off x="865238" y="452283"/>
+            <a:ext cx="7374194" cy="553998"/>
           </a:xfrm>
           <a:prstGeom prst="rect">
             <a:avLst/>
           </a:prstGeom>
           <a:noFill/>
-          <a:ln/>
-        </p:spPr>
-        <p:txBody>
-          <a:bodyPr wrap="square" rtlCol="0" anchor="ctr"/>
-          <a:lstStyle/>
-          <a:p>
-            <a:pPr indent="0" marL="0">
-              <a:buNone/>
-            </a:pPr>
+        </p:spPr>
+        <p:txBody>
+          <a:bodyPr wrap="square" rtlCol="0">
+            <a:spAutoFit/>
+          </a:bodyPr>
+          <a:lstStyle/>
+          <a:p>
             <a:r>
               <a:rPr lang="en-US" sz="3000" b="1" dirty="0">
                 <a:solidFill>
@@ -10855,198 +11195,98 @@
                 <a:ea typeface="Calibri" pitchFamily="34" charset="-122"/>
                 <a:cs typeface="Calibri" pitchFamily="34" charset="-120"/>
               </a:rPr>
-              <a:t>Dashboard: Industry Overview &amp; Fund Performance</a:t>
+              <a:t>Performance Metrics: Advanced Risk Insights</a:t>
             </a:r>
-            <a:endParaRPr lang="en-US" sz="3000" dirty="0"/>
-          </a:p>
-        </p:txBody>
-      </p:sp>
-      <p:pic>
-        <p:nvPicPr>
-          <p:cNvPr id="3" name="Image 0" descr="/home/claude/pptx_build/images/page1_industry_overview.png">    </p:cNvPr>
-          <p:cNvPicPr>
-            <a:picLocks noChangeAspect="1"/>
-          </p:cNvPicPr>
-          <p:nvPr/>
-        </p:nvPicPr>
-        <p:blipFill>
-          <a:blip r:embed="rId1"/>
-          <a:stretch>
-            <a:fillRect/>
-          </a:stretch>
-        </p:blipFill>
-        <p:spPr>
-          <a:xfrm>
-            <a:off x="365760" y="1554480"/>
-            <a:ext cx="5806440" cy="3566160"/>
+          </a:p>
+        </p:txBody>
+      </p:sp>
+      <p:sp>
+        <p:nvSpPr>
+          <p:cNvPr id="5" name="TextBox 4">
+            <a:extLst>
+              <a:ext uri="{FF2B5EF4-FFF2-40B4-BE49-F238E27FC236}">
+                <a16:creationId xmlns:a16="http://schemas.microsoft.com/office/drawing/2014/main" id="{55721024-5C60-71D0-7A06-D7D82C45A379}"/>
+              </a:ext>
+            </a:extLst>
+          </p:cNvPr>
+          <p:cNvSpPr txBox="1"/>
+          <p:nvPr/>
+        </p:nvSpPr>
+        <p:spPr>
+          <a:xfrm>
+            <a:off x="845574" y="1799303"/>
+            <a:ext cx="7511845" cy="2308324"/>
           </a:xfrm>
           <a:prstGeom prst="rect">
             <a:avLst/>
           </a:prstGeom>
-        </p:spPr>
-      </p:pic>
-      <p:pic>
-        <p:nvPicPr>
-          <p:cNvPr id="4" name="Image 1" descr="/home/claude/pptx_build/images/page2_fund_performance.png">    </p:cNvPr>
-          <p:cNvPicPr>
-            <a:picLocks noChangeAspect="1"/>
-          </p:cNvPicPr>
-          <p:nvPr/>
-        </p:nvPicPr>
-        <p:blipFill>
-          <a:blip r:embed="rId2"/>
-          <a:stretch>
-            <a:fillRect/>
-          </a:stretch>
-        </p:blipFill>
-        <p:spPr>
-          <a:xfrm>
-            <a:off x="6309360" y="1554480"/>
-            <a:ext cx="5440680" cy="3566160"/>
-          </a:xfrm>
-          <a:prstGeom prst="rect">
-            <a:avLst/>
-          </a:prstGeom>
-        </p:spPr>
-      </p:pic>
-      <p:sp>
-        <p:nvSpPr>
-          <p:cNvPr id="5" name="Shape 1"/>
-          <p:cNvSpPr/>
-          <p:nvPr/>
-        </p:nvSpPr>
-        <p:spPr>
-          <a:xfrm>
-            <a:off x="365760" y="5257800"/>
-            <a:ext cx="11384280" cy="1051560"/>
-          </a:xfrm>
-          <a:prstGeom prst="rect">
-            <a:avLst/>
-          </a:prstGeom>
-          <a:solidFill>
-            <a:srgbClr val="F2F0F7"/>
-          </a:solidFill>
-          <a:ln/>
-        </p:spPr>
-      </p:sp>
-      <p:sp>
-        <p:nvSpPr>
-          <p:cNvPr id="6" name="Text 2"/>
-          <p:cNvSpPr/>
-          <p:nvPr/>
-        </p:nvSpPr>
-        <p:spPr>
-          <a:xfrm>
-            <a:off x="685800" y="5394960"/>
-            <a:ext cx="10744200" cy="777240"/>
-          </a:xfrm>
-          <a:prstGeom prst="rect">
-            <a:avLst/>
-          </a:prstGeom>
           <a:noFill/>
-          <a:ln/>
-        </p:spPr>
-        <p:txBody>
-          <a:bodyPr wrap="square" rtlCol="0" anchor="ctr"/>
-          <a:lstStyle/>
-          <a:p>
-            <a:pPr indent="0" marL="0">
-              <a:buNone/>
+        </p:spPr>
+        <p:txBody>
+          <a:bodyPr wrap="square" rtlCol="0">
+            <a:spAutoFit/>
+          </a:bodyPr>
+          <a:lstStyle/>
+          <a:p>
+            <a:pPr marL="285750" lvl="0" indent="-285750">
+              <a:buFont typeface="Arial" panose="020B0604020202020204" pitchFamily="34" charset="0"/>
+              <a:buChar char="•"/>
             </a:pPr>
             <a:r>
-              <a:rPr lang="en-US" sz="1300" dirty="0">
-                <a:solidFill>
-                  <a:srgbClr val="1F1F1F"/>
-                </a:solidFill>
-                <a:latin typeface="Calibri" pitchFamily="34" charset="0"/>
-                <a:ea typeface="Calibri" pitchFamily="34" charset="-122"/>
-                <a:cs typeface="Calibri" pitchFamily="34" charset="-120"/>
-              </a:rPr>
-              <a:t>4-page interactive Power BI dashboard with KPI cards, AUM trends, a return-vs-risk scatter plot, and a sortable fund scorecard — plus drill-through to per-fund NAV detail.</a:t>
+              <a:rPr lang="en-US" dirty="0"/>
+              <a:t>Computed Historical </a:t>
             </a:r>
-            <a:endParaRPr lang="en-US" sz="1300" dirty="0"/>
-          </a:p>
-        </p:txBody>
-      </p:sp>
-      <p:sp>
-        <p:nvSpPr>
-          <p:cNvPr id="7" name="Text 3"/>
-          <p:cNvSpPr/>
-          <p:nvPr/>
-        </p:nvSpPr>
-        <p:spPr>
-          <a:xfrm>
-            <a:off x="365760" y="6537960"/>
-            <a:ext cx="7315200" cy="274320"/>
-          </a:xfrm>
-          <a:prstGeom prst="rect">
-            <a:avLst/>
-          </a:prstGeom>
-          <a:noFill/>
-          <a:ln/>
-        </p:spPr>
-        <p:txBody>
-          <a:bodyPr wrap="square" rtlCol="0" anchor="ctr"/>
-          <a:lstStyle/>
-          <a:p>
-            <a:pPr indent="0" marL="0">
-              <a:buNone/>
+            <a:r>
+              <a:rPr lang="en-US" dirty="0" err="1"/>
+              <a:t>VaR</a:t>
+            </a:r>
+            <a:r>
+              <a:rPr lang="en-US" dirty="0"/>
+              <a:t> &amp; CVaR (95%) across all 40 schemes to quantify single-day downside risk</a:t>
+            </a:r>
+          </a:p>
+          <a:p>
+            <a:pPr marL="285750" lvl="0" indent="-285750">
+              <a:buFont typeface="Arial" panose="020B0604020202020204" pitchFamily="34" charset="0"/>
+              <a:buChar char="•"/>
             </a:pPr>
             <a:r>
-              <a:rPr lang="en-US" sz="900" dirty="0">
-                <a:solidFill>
-                  <a:srgbClr val="595959"/>
-                </a:solidFill>
-                <a:latin typeface="Calibri" pitchFamily="34" charset="0"/>
-                <a:ea typeface="Calibri" pitchFamily="34" charset="-122"/>
-                <a:cs typeface="Calibri" pitchFamily="34" charset="-120"/>
-              </a:rPr>
-              <a:t>Bluestock Fintech — Mutual Fund Analytics Capstone</a:t>
+              <a:rPr lang="en-US" dirty="0"/>
+              <a:t>Rolling 90-day Sharpe ratio shows risk-adjusted return fluctuates meaningfully over time — not a fixed number</a:t>
             </a:r>
-            <a:endParaRPr lang="en-US" sz="900" dirty="0"/>
-          </a:p>
-        </p:txBody>
-      </p:sp>
-      <p:sp>
-        <p:nvSpPr>
-          <p:cNvPr id="8" name="Text 4"/>
-          <p:cNvSpPr/>
-          <p:nvPr/>
-        </p:nvSpPr>
-        <p:spPr>
-          <a:xfrm>
-            <a:off x="11521440" y="6537960"/>
-            <a:ext cx="365760" cy="274320"/>
-          </a:xfrm>
-          <a:prstGeom prst="rect">
-            <a:avLst/>
-          </a:prstGeom>
-          <a:noFill/>
-          <a:ln/>
-        </p:spPr>
-        <p:txBody>
-          <a:bodyPr wrap="square" rtlCol="0" anchor="ctr"/>
-          <a:lstStyle/>
-          <a:p>
-            <a:pPr algn="r" indent="0" marL="0">
-              <a:buNone/>
+          </a:p>
+          <a:p>
+            <a:pPr marL="285750" lvl="0" indent="-285750">
+              <a:buFont typeface="Arial" panose="020B0604020202020204" pitchFamily="34" charset="0"/>
+              <a:buChar char="•"/>
             </a:pPr>
             <a:r>
-              <a:rPr lang="en-US" sz="900" dirty="0">
-                <a:solidFill>
-                  <a:srgbClr val="595959"/>
-                </a:solidFill>
-                <a:latin typeface="Calibri" pitchFamily="34" charset="0"/>
-                <a:ea typeface="Calibri" pitchFamily="34" charset="-122"/>
-                <a:cs typeface="Calibri" pitchFamily="34" charset="-120"/>
-              </a:rPr>
-              <a:t>9</a:t>
+              <a:rPr lang="en-US" b="1" dirty="0"/>
+              <a:t> 97.8%</a:t>
             </a:r>
-            <a:endParaRPr lang="en-US" sz="900" dirty="0"/>
+            <a:r>
+              <a:rPr lang="en-US" dirty="0"/>
+              <a:t> of investors with 6+ SIPs flagged "at-risk" of discontinuation (gap &gt; 35 days between contributions)</a:t>
+            </a:r>
+          </a:p>
+          <a:p>
+            <a:pPr marL="285750" lvl="0" indent="-285750">
+              <a:buFont typeface="Arial" panose="020B0604020202020204" pitchFamily="34" charset="0"/>
+              <a:buChar char="•"/>
+            </a:pPr>
+            <a:r>
+              <a:rPr lang="en-US" dirty="0"/>
+              <a:t>Sector concentration (HHI) analysis identifies which equity funds are diversified vs. concentrated</a:t>
+            </a:r>
           </a:p>
         </p:txBody>
       </p:sp>
     </p:spTree>
+    <p:extLst>
+      <p:ext uri="{BB962C8B-B14F-4D97-AF65-F5344CB8AC3E}">
+        <p14:creationId xmlns:p14="http://schemas.microsoft.com/office/powerpoint/2010/main" val="2220305774"/>
+      </p:ext>
+    </p:extLst>
   </p:cSld>
   <p:clrMapOvr>
     <a:masterClrMapping/>
@@ -11347,4 +11587,319 @@
     </a:ext>
   </a:extLst>
 </a:theme>
+</file>
+
+<file path=ppt/theme/theme2.xml><?xml version="1.0" encoding="utf-8"?>
+<a:theme xmlns:a="http://schemas.openxmlformats.org/drawingml/2006/main" name="Office Theme">
+  <a:themeElements>
+    <a:clrScheme name="Office">
+      <a:dk1>
+        <a:sysClr val="windowText" lastClr="000000"/>
+      </a:dk1>
+      <a:lt1>
+        <a:sysClr val="window" lastClr="FFFFFF"/>
+      </a:lt1>
+      <a:dk2>
+        <a:srgbClr val="0E2841"/>
+      </a:dk2>
+      <a:lt2>
+        <a:srgbClr val="E8E8E8"/>
+      </a:lt2>
+      <a:accent1>
+        <a:srgbClr val="156082"/>
+      </a:accent1>
+      <a:accent2>
+        <a:srgbClr val="E97132"/>
+      </a:accent2>
+      <a:accent3>
+        <a:srgbClr val="196B24"/>
+      </a:accent3>
+      <a:accent4>
+        <a:srgbClr val="0F9ED5"/>
+      </a:accent4>
+      <a:accent5>
+        <a:srgbClr val="A02B93"/>
+      </a:accent5>
+      <a:accent6>
+        <a:srgbClr val="4EA72E"/>
+      </a:accent6>
+      <a:hlink>
+        <a:srgbClr val="467886"/>
+      </a:hlink>
+      <a:folHlink>
+        <a:srgbClr val="96607D"/>
+      </a:folHlink>
+    </a:clrScheme>
+    <a:fontScheme name="Office">
+      <a:majorFont>
+        <a:latin typeface="Aptos Display" panose="02110004020202020204"/>
+        <a:ea typeface=""/>
+        <a:cs typeface=""/>
+        <a:font script="Jpan" typeface="游ゴシック Light"/>
+        <a:font script="Hang" typeface="맑은 고딕"/>
+        <a:font script="Hans" typeface="等线 Light"/>
+        <a:font script="Hant" typeface="新細明體"/>
+        <a:font script="Arab" typeface="Times New Roman"/>
+        <a:font script="Hebr" typeface="Times New Roman"/>
+        <a:font script="Thai" typeface="Angsana New"/>
+        <a:font script="Ethi" typeface="Nyala"/>
+        <a:font script="Beng" typeface="Vrinda"/>
+        <a:font script="Gujr" typeface="Shruti"/>
+        <a:font script="Khmr" typeface="MoolBoran"/>
+        <a:font script="Knda" typeface="Tunga"/>
+        <a:font script="Guru" typeface="Raavi"/>
+        <a:font script="Cans" typeface="Euphemia"/>
+        <a:font script="Cher" typeface="Plantagenet Cherokee"/>
+        <a:font script="Yiii" typeface="Microsoft Yi Baiti"/>
+        <a:font script="Tibt" typeface="Microsoft Himalaya"/>
+        <a:font script="Thaa" typeface="MV Boli"/>
+        <a:font script="Deva" typeface="Mangal"/>
+        <a:font script="Telu" typeface="Gautami"/>
+        <a:font script="Taml" typeface="Latha"/>
+        <a:font script="Syrc" typeface="Estrangelo Edessa"/>
+        <a:font script="Orya" typeface="Kalinga"/>
+        <a:font script="Mlym" typeface="Kartika"/>
+        <a:font script="Laoo" typeface="DokChampa"/>
+        <a:font script="Sinh" typeface="Iskoola Pota"/>
+        <a:font script="Mong" typeface="Mongolian Baiti"/>
+        <a:font script="Viet" typeface="Times New Roman"/>
+        <a:font script="Uigh" typeface="Microsoft Uighur"/>
+        <a:font script="Geor" typeface="Sylfaen"/>
+        <a:font script="Armn" typeface="Arial"/>
+        <a:font script="Bugi" typeface="Leelawadee UI"/>
+        <a:font script="Bopo" typeface="Microsoft JhengHei"/>
+        <a:font script="Java" typeface="Javanese Text"/>
+        <a:font script="Lisu" typeface="Segoe UI"/>
+        <a:font script="Mymr" typeface="Myanmar Text"/>
+        <a:font script="Nkoo" typeface="Ebrima"/>
+        <a:font script="Olck" typeface="Nirmala UI"/>
+        <a:font script="Osma" typeface="Ebrima"/>
+        <a:font script="Phag" typeface="Phagspa"/>
+        <a:font script="Syrn" typeface="Estrangelo Edessa"/>
+        <a:font script="Syrj" typeface="Estrangelo Edessa"/>
+        <a:font script="Syre" typeface="Estrangelo Edessa"/>
+        <a:font script="Sora" typeface="Nirmala UI"/>
+        <a:font script="Tale" typeface="Microsoft Tai Le"/>
+        <a:font script="Talu" typeface="Microsoft New Tai Lue"/>
+        <a:font script="Tfng" typeface="Ebrima"/>
+      </a:majorFont>
+      <a:minorFont>
+        <a:latin typeface="Aptos" panose="02110004020202020204"/>
+        <a:ea typeface=""/>
+        <a:cs typeface=""/>
+        <a:font script="Jpan" typeface="游ゴシック"/>
+        <a:font script="Hang" typeface="맑은 고딕"/>
+        <a:font script="Hans" typeface="等线"/>
+        <a:font script="Hant" typeface="新細明體"/>
+        <a:font script="Arab" typeface="Arial"/>
+        <a:font script="Hebr" typeface="Arial"/>
+        <a:font script="Thai" typeface="Cordia New"/>
+        <a:font script="Ethi" typeface="Nyala"/>
+        <a:font script="Beng" typeface="Vrinda"/>
+        <a:font script="Gujr" typeface="Shruti"/>
+        <a:font script="Khmr" typeface="DaunPenh"/>
+        <a:font script="Knda" typeface="Tunga"/>
+        <a:font script="Guru" typeface="Raavi"/>
+        <a:font script="Cans" typeface="Euphemia"/>
+        <a:font script="Cher" typeface="Plantagenet Cherokee"/>
+        <a:font script="Yiii" typeface="Microsoft Yi Baiti"/>
+        <a:font script="Tibt" typeface="Microsoft Himalaya"/>
+        <a:font script="Thaa" typeface="MV Boli"/>
+        <a:font script="Deva" typeface="Mangal"/>
+        <a:font script="Telu" typeface="Gautami"/>
+        <a:font script="Taml" typeface="Latha"/>
+        <a:font script="Syrc" typeface="Estrangelo Edessa"/>
+        <a:font script="Orya" typeface="Kalinga"/>
+        <a:font script="Mlym" typeface="Kartika"/>
+        <a:font script="Laoo" typeface="DokChampa"/>
+        <a:font script="Sinh" typeface="Iskoola Pota"/>
+        <a:font script="Mong" typeface="Mongolian Baiti"/>
+        <a:font script="Viet" typeface="Arial"/>
+        <a:font script="Uigh" typeface="Microsoft Uighur"/>
+        <a:font script="Geor" typeface="Sylfaen"/>
+        <a:font script="Armn" typeface="Arial"/>
+        <a:font script="Bugi" typeface="Leelawadee UI"/>
+        <a:font script="Bopo" typeface="Microsoft JhengHei"/>
+        <a:font script="Java" typeface="Javanese Text"/>
+        <a:font script="Lisu" typeface="Segoe UI"/>
+        <a:font script="Mymr" typeface="Myanmar Text"/>
+        <a:font script="Nkoo" typeface="Ebrima"/>
+        <a:font script="Olck" typeface="Nirmala UI"/>
+        <a:font script="Osma" typeface="Ebrima"/>
+        <a:font script="Phag" typeface="Phagspa"/>
+        <a:font script="Syrn" typeface="Estrangelo Edessa"/>
+        <a:font script="Syrj" typeface="Estrangelo Edessa"/>
+        <a:font script="Syre" typeface="Estrangelo Edessa"/>
+        <a:font script="Sora" typeface="Nirmala UI"/>
+        <a:font script="Tale" typeface="Microsoft Tai Le"/>
+        <a:font script="Talu" typeface="Microsoft New Tai Lue"/>
+        <a:font script="Tfng" typeface="Ebrima"/>
+      </a:minorFont>
+    </a:fontScheme>
+    <a:fmtScheme name="Office">
+      <a:fillStyleLst>
+        <a:solidFill>
+          <a:schemeClr val="phClr"/>
+        </a:solidFill>
+        <a:gradFill rotWithShape="1">
+          <a:gsLst>
+            <a:gs pos="0">
+              <a:schemeClr val="phClr">
+                <a:lumMod val="110000"/>
+                <a:satMod val="105000"/>
+                <a:tint val="67000"/>
+              </a:schemeClr>
+            </a:gs>
+            <a:gs pos="50000">
+              <a:schemeClr val="phClr">
+                <a:lumMod val="105000"/>
+                <a:satMod val="103000"/>
+                <a:tint val="73000"/>
+              </a:schemeClr>
+            </a:gs>
+            <a:gs pos="100000">
+              <a:schemeClr val="phClr">
+                <a:lumMod val="105000"/>
+                <a:satMod val="109000"/>
+                <a:tint val="81000"/>
+              </a:schemeClr>
+            </a:gs>
+          </a:gsLst>
+          <a:lin ang="5400000" scaled="0"/>
+        </a:gradFill>
+        <a:gradFill rotWithShape="1">
+          <a:gsLst>
+            <a:gs pos="0">
+              <a:schemeClr val="phClr">
+                <a:satMod val="103000"/>
+                <a:lumMod val="102000"/>
+                <a:tint val="94000"/>
+              </a:schemeClr>
+            </a:gs>
+            <a:gs pos="50000">
+              <a:schemeClr val="phClr">
+                <a:satMod val="110000"/>
+                <a:lumMod val="100000"/>
+                <a:shade val="100000"/>
+              </a:schemeClr>
+            </a:gs>
+            <a:gs pos="100000">
+              <a:schemeClr val="phClr">
+                <a:lumMod val="99000"/>
+                <a:satMod val="120000"/>
+                <a:shade val="78000"/>
+              </a:schemeClr>
+            </a:gs>
+          </a:gsLst>
+          <a:lin ang="5400000" scaled="0"/>
+        </a:gradFill>
+      </a:fillStyleLst>
+      <a:lnStyleLst>
+        <a:ln w="12700" cap="flat" cmpd="sng" algn="ctr">
+          <a:solidFill>
+            <a:schemeClr val="phClr"/>
+          </a:solidFill>
+          <a:prstDash val="solid"/>
+          <a:miter lim="800000"/>
+        </a:ln>
+        <a:ln w="19050" cap="flat" cmpd="sng" algn="ctr">
+          <a:solidFill>
+            <a:schemeClr val="phClr"/>
+          </a:solidFill>
+          <a:prstDash val="solid"/>
+          <a:miter lim="800000"/>
+        </a:ln>
+        <a:ln w="25400" cap="flat" cmpd="sng" algn="ctr">
+          <a:solidFill>
+            <a:schemeClr val="phClr"/>
+          </a:solidFill>
+          <a:prstDash val="solid"/>
+          <a:miter lim="800000"/>
+        </a:ln>
+      </a:lnStyleLst>
+      <a:effectStyleLst>
+        <a:effectStyle>
+          <a:effectLst/>
+        </a:effectStyle>
+        <a:effectStyle>
+          <a:effectLst/>
+        </a:effectStyle>
+        <a:effectStyle>
+          <a:effectLst>
+            <a:outerShdw blurRad="57150" dist="19050" dir="5400000" algn="ctr" rotWithShape="0">
+              <a:srgbClr val="000000">
+                <a:alpha val="63000"/>
+              </a:srgbClr>
+            </a:outerShdw>
+          </a:effectLst>
+        </a:effectStyle>
+      </a:effectStyleLst>
+      <a:bgFillStyleLst>
+        <a:solidFill>
+          <a:schemeClr val="phClr"/>
+        </a:solidFill>
+        <a:solidFill>
+          <a:schemeClr val="phClr">
+            <a:tint val="95000"/>
+            <a:satMod val="170000"/>
+          </a:schemeClr>
+        </a:solidFill>
+        <a:gradFill rotWithShape="1">
+          <a:gsLst>
+            <a:gs pos="0">
+              <a:schemeClr val="phClr">
+                <a:tint val="93000"/>
+                <a:satMod val="150000"/>
+                <a:shade val="98000"/>
+                <a:lumMod val="102000"/>
+              </a:schemeClr>
+            </a:gs>
+            <a:gs pos="50000">
+              <a:schemeClr val="phClr">
+                <a:tint val="98000"/>
+                <a:satMod val="130000"/>
+                <a:shade val="90000"/>
+                <a:lumMod val="103000"/>
+              </a:schemeClr>
+            </a:gs>
+            <a:gs pos="100000">
+              <a:schemeClr val="phClr">
+                <a:shade val="63000"/>
+                <a:satMod val="120000"/>
+              </a:schemeClr>
+            </a:gs>
+          </a:gsLst>
+          <a:lin ang="5400000" scaled="0"/>
+        </a:gradFill>
+      </a:bgFillStyleLst>
+    </a:fmtScheme>
+  </a:themeElements>
+  <a:objectDefaults>
+    <a:lnDef>
+      <a:spPr/>
+      <a:bodyPr/>
+      <a:lstStyle/>
+      <a:style>
+        <a:lnRef idx="2">
+          <a:schemeClr val="accent1"/>
+        </a:lnRef>
+        <a:fillRef idx="0">
+          <a:schemeClr val="accent1"/>
+        </a:fillRef>
+        <a:effectRef idx="1">
+          <a:schemeClr val="accent1"/>
+        </a:effectRef>
+        <a:fontRef idx="minor">
+          <a:schemeClr val="tx1"/>
+        </a:fontRef>
+      </a:style>
+    </a:lnDef>
+  </a:objectDefaults>
+  <a:extraClrSchemeLst/>
+  <a:extLst>
+    <a:ext uri="{05A4C25C-085E-4340-85A3-A5531E510DB2}">
+      <thm15:themeFamily xmlns:thm15="http://schemas.microsoft.com/office/thememl/2012/main" name="Office Theme" id="{2E142A2C-CD16-42D6-873A-C26D2A0506FA}" vid="{1BDDFF52-6CD6-40A5-AB3C-68EB2F1E4D0A}"/>
+    </a:ext>
+  </a:extLst>
+</a:theme>
 </file>
</xml_diff>